<commit_message>
Brighten Python presentation palette for higher contrast
Switch from murky dark theme to vivid light sky blues, oranges,
and greens with navy text so slides read clearly on projectors.

Co-authored-by: Dilshod Zokirov <DilshodZokirov@users.noreply.github.com>
</commit_message>
<xml_diff>
--- a/python-prezentatsiya/Python-Django-Vaaav.pptx
+++ b/python-prezentatsiya/Python-Django-Vaaav.pptx
@@ -3118,7 +3118,7 @@
             <a:avLst/>
           </a:prstGeom>
           <a:solidFill>
-            <a:srgbClr val="0B1422"/>
+            <a:srgbClr val="EFF8FF"/>
           </a:solidFill>
           <a:ln>
             <a:noFill/>
@@ -3161,7 +3161,7 @@
             <a:avLst/>
           </a:prstGeom>
           <a:solidFill>
-            <a:srgbClr val="2ED3B7"/>
+            <a:srgbClr val="009EE0"/>
           </a:solidFill>
           <a:ln>
             <a:noFill/>
@@ -3204,7 +3204,7 @@
             <a:avLst/>
           </a:prstGeom>
           <a:solidFill>
-            <a:srgbClr val="1A3A55"/>
+            <a:srgbClr val="7ED6FF"/>
           </a:solidFill>
           <a:ln>
             <a:noFill/>
@@ -3247,7 +3247,7 @@
             <a:avLst/>
           </a:prstGeom>
           <a:solidFill>
-            <a:srgbClr val="143530"/>
+            <a:srgbClr val="FFD080"/>
           </a:solidFill>
           <a:ln>
             <a:noFill/>
@@ -3290,7 +3290,7 @@
             <a:avLst/>
           </a:prstGeom>
           <a:solidFill>
-            <a:srgbClr val="2ED3B7"/>
+            <a:srgbClr val="009EE0"/>
           </a:solidFill>
           <a:ln>
             <a:noFill/>
@@ -3348,7 +3348,7 @@
                 <a:cs typeface="Calibri"/>
                 <a:ea typeface="Calibri"/>
                 <a:solidFill>
-                  <a:srgbClr val="0B1422"/>
+                  <a:srgbClr val="EFF8FF"/>
                 </a:solidFill>
                 <a:latin typeface="Calibri"/>
               </a:rPr>
@@ -3387,7 +3387,7 @@
                 <a:cs typeface="Calibri"/>
                 <a:ea typeface="Calibri"/>
                 <a:solidFill>
-                  <a:srgbClr val="9AB0C6"/>
+                  <a:srgbClr val="3D556B"/>
                 </a:solidFill>
                 <a:latin typeface="Calibri"/>
               </a:rPr>
@@ -3405,7 +3405,7 @@
                 <a:cs typeface="Calibri"/>
                 <a:ea typeface="Calibri"/>
                 <a:solidFill>
-                  <a:srgbClr val="FFFFFF"/>
+                  <a:srgbClr val="0B3D6E"/>
                 </a:solidFill>
                 <a:latin typeface="Calibri"/>
               </a:rPr>
@@ -3423,7 +3423,7 @@
                 <a:cs typeface="Calibri"/>
                 <a:ea typeface="Calibri"/>
                 <a:solidFill>
-                  <a:srgbClr val="9AB0C6"/>
+                  <a:srgbClr val="3D556B"/>
                 </a:solidFill>
                 <a:latin typeface="Calibri"/>
               </a:rPr>
@@ -3462,7 +3462,7 @@
                 <a:cs typeface="Calibri"/>
                 <a:ea typeface="Calibri"/>
                 <a:solidFill>
-                  <a:srgbClr val="F5B32E"/>
+                  <a:srgbClr val="FF8C00"/>
                 </a:solidFill>
                 <a:latin typeface="Calibri"/>
               </a:rPr>
@@ -3504,7 +3504,7 @@
             <a:avLst/>
           </a:prstGeom>
           <a:solidFill>
-            <a:srgbClr val="0B1422"/>
+            <a:srgbClr val="EFF8FF"/>
           </a:solidFill>
           <a:ln>
             <a:noFill/>
@@ -3547,7 +3547,7 @@
             <a:avLst/>
           </a:prstGeom>
           <a:solidFill>
-            <a:srgbClr val="2ED3B7"/>
+            <a:srgbClr val="009EE0"/>
           </a:solidFill>
           <a:ln>
             <a:noFill/>
@@ -3605,7 +3605,7 @@
                 <a:cs typeface="Calibri"/>
                 <a:ea typeface="Calibri"/>
                 <a:solidFill>
-                  <a:srgbClr val="F5B32E"/>
+                  <a:srgbClr val="FF8C00"/>
                 </a:solidFill>
                 <a:latin typeface="Calibri"/>
               </a:rPr>
@@ -3623,7 +3623,7 @@
                 <a:cs typeface="Calibri"/>
                 <a:ea typeface="Calibri"/>
                 <a:solidFill>
-                  <a:srgbClr val="FFFFFF"/>
+                  <a:srgbClr val="0B3D6E"/>
                 </a:solidFill>
                 <a:latin typeface="Calibri"/>
               </a:rPr>
@@ -3647,11 +3647,11 @@
             <a:avLst/>
           </a:prstGeom>
           <a:solidFill>
-            <a:srgbClr val="162A44"/>
-          </a:solidFill>
-          <a:ln>
+            <a:srgbClr val="FFFFFF"/>
+          </a:solidFill>
+          <a:ln w="28575">
             <a:solidFill>
-              <a:srgbClr val="2A405C"/>
+              <a:srgbClr val="009EE0"/>
             </a:solidFill>
           </a:ln>
         </p:spPr>
@@ -3686,13 +3686,13 @@
         <p:spPr>
           <a:xfrm>
             <a:off x="502920" y="1417320"/>
-            <a:ext cx="91440" cy="2240280"/>
-          </a:xfrm>
-          <a:prstGeom prst="rect">
-            <a:avLst/>
-          </a:prstGeom>
-          <a:solidFill>
-            <a:srgbClr val="2ED3B7"/>
+            <a:ext cx="128016" cy="2240280"/>
+          </a:xfrm>
+          <a:prstGeom prst="rect">
+            <a:avLst/>
+          </a:prstGeom>
+          <a:solidFill>
+            <a:srgbClr val="009EE0"/>
           </a:solidFill>
           <a:ln>
             <a:noFill/>
@@ -3728,8 +3728,8 @@
         </p:nvSpPr>
         <p:spPr>
           <a:xfrm>
-            <a:off x="758952" y="1618488"/>
-            <a:ext cx="3291840" cy="1920240"/>
+            <a:off x="795528" y="1618488"/>
+            <a:ext cx="3246120" cy="1920240"/>
           </a:xfrm>
           <a:prstGeom prst="rect">
             <a:avLst/>
@@ -3750,7 +3750,7 @@
                 <a:cs typeface="Calibri"/>
                 <a:ea typeface="Calibri"/>
                 <a:solidFill>
-                  <a:srgbClr val="FFFFFF"/>
+                  <a:srgbClr val="0B3D6E"/>
                 </a:solidFill>
                 <a:latin typeface="Calibri"/>
               </a:rPr>
@@ -3768,7 +3768,7 @@
                 <a:cs typeface="Calibri"/>
                 <a:ea typeface="Calibri"/>
                 <a:solidFill>
-                  <a:srgbClr val="9AB0C6"/>
+                  <a:srgbClr val="3D556B"/>
                 </a:solidFill>
                 <a:latin typeface="Calibri"/>
               </a:rPr>
@@ -3793,11 +3793,11 @@
             <a:avLst/>
           </a:prstGeom>
           <a:solidFill>
-            <a:srgbClr val="162A44"/>
-          </a:solidFill>
-          <a:ln>
+            <a:srgbClr val="FFFFFF"/>
+          </a:solidFill>
+          <a:ln w="28575">
             <a:solidFill>
-              <a:srgbClr val="2A405C"/>
+              <a:srgbClr val="009EE0"/>
             </a:solidFill>
           </a:ln>
         </p:spPr>
@@ -3832,13 +3832,13 @@
         <p:spPr>
           <a:xfrm>
             <a:off x="4343400" y="1417320"/>
-            <a:ext cx="91440" cy="2240280"/>
-          </a:xfrm>
-          <a:prstGeom prst="rect">
-            <a:avLst/>
-          </a:prstGeom>
-          <a:solidFill>
-            <a:srgbClr val="2ED3B7"/>
+            <a:ext cx="128016" cy="2240280"/>
+          </a:xfrm>
+          <a:prstGeom prst="rect">
+            <a:avLst/>
+          </a:prstGeom>
+          <a:solidFill>
+            <a:srgbClr val="009EE0"/>
           </a:solidFill>
           <a:ln>
             <a:noFill/>
@@ -3874,8 +3874,8 @@
         </p:nvSpPr>
         <p:spPr>
           <a:xfrm>
-            <a:off x="4599432" y="1618488"/>
-            <a:ext cx="3291840" cy="1920240"/>
+            <a:off x="4636008" y="1618488"/>
+            <a:ext cx="3246120" cy="1920240"/>
           </a:xfrm>
           <a:prstGeom prst="rect">
             <a:avLst/>
@@ -3896,7 +3896,7 @@
                 <a:cs typeface="Calibri"/>
                 <a:ea typeface="Calibri"/>
                 <a:solidFill>
-                  <a:srgbClr val="FFFFFF"/>
+                  <a:srgbClr val="0B3D6E"/>
                 </a:solidFill>
                 <a:latin typeface="Calibri"/>
               </a:rPr>
@@ -3914,7 +3914,7 @@
                 <a:cs typeface="Calibri"/>
                 <a:ea typeface="Calibri"/>
                 <a:solidFill>
-                  <a:srgbClr val="9AB0C6"/>
+                  <a:srgbClr val="3D556B"/>
                 </a:solidFill>
                 <a:latin typeface="Calibri"/>
               </a:rPr>
@@ -3939,11 +3939,11 @@
             <a:avLst/>
           </a:prstGeom>
           <a:solidFill>
-            <a:srgbClr val="162A44"/>
-          </a:solidFill>
-          <a:ln>
+            <a:srgbClr val="FFFFFF"/>
+          </a:solidFill>
+          <a:ln w="28575">
             <a:solidFill>
-              <a:srgbClr val="2A405C"/>
+              <a:srgbClr val="FF8C00"/>
             </a:solidFill>
           </a:ln>
         </p:spPr>
@@ -3978,13 +3978,13 @@
         <p:spPr>
           <a:xfrm>
             <a:off x="8183880" y="1417320"/>
-            <a:ext cx="91440" cy="2240280"/>
-          </a:xfrm>
-          <a:prstGeom prst="rect">
-            <a:avLst/>
-          </a:prstGeom>
-          <a:solidFill>
-            <a:srgbClr val="F5B32E"/>
+            <a:ext cx="128016" cy="2240280"/>
+          </a:xfrm>
+          <a:prstGeom prst="rect">
+            <a:avLst/>
+          </a:prstGeom>
+          <a:solidFill>
+            <a:srgbClr val="FF8C00"/>
           </a:solidFill>
           <a:ln>
             <a:noFill/>
@@ -4020,8 +4020,8 @@
         </p:nvSpPr>
         <p:spPr>
           <a:xfrm>
-            <a:off x="8439912" y="1618488"/>
-            <a:ext cx="3291840" cy="1920240"/>
+            <a:off x="8476488" y="1618488"/>
+            <a:ext cx="3246120" cy="1920240"/>
           </a:xfrm>
           <a:prstGeom prst="rect">
             <a:avLst/>
@@ -4042,7 +4042,7 @@
                 <a:cs typeface="Calibri"/>
                 <a:ea typeface="Calibri"/>
                 <a:solidFill>
-                  <a:srgbClr val="FFFFFF"/>
+                  <a:srgbClr val="0B3D6E"/>
                 </a:solidFill>
                 <a:latin typeface="Calibri"/>
               </a:rPr>
@@ -4060,7 +4060,7 @@
                 <a:cs typeface="Calibri"/>
                 <a:ea typeface="Calibri"/>
                 <a:solidFill>
-                  <a:srgbClr val="9AB0C6"/>
+                  <a:srgbClr val="3D556B"/>
                 </a:solidFill>
                 <a:latin typeface="Calibri"/>
               </a:rPr>
@@ -4085,11 +4085,11 @@
             <a:avLst/>
           </a:prstGeom>
           <a:solidFill>
-            <a:srgbClr val="162A44"/>
-          </a:solidFill>
-          <a:ln>
+            <a:srgbClr val="FFFFFF"/>
+          </a:solidFill>
+          <a:ln w="28575">
             <a:solidFill>
-              <a:srgbClr val="2A405C"/>
+              <a:srgbClr val="FF8C00"/>
             </a:solidFill>
           </a:ln>
         </p:spPr>
@@ -4124,13 +4124,13 @@
         <p:spPr>
           <a:xfrm>
             <a:off x="502920" y="3886200"/>
-            <a:ext cx="91440" cy="2240280"/>
-          </a:xfrm>
-          <a:prstGeom prst="rect">
-            <a:avLst/>
-          </a:prstGeom>
-          <a:solidFill>
-            <a:srgbClr val="F5B32E"/>
+            <a:ext cx="128016" cy="2240280"/>
+          </a:xfrm>
+          <a:prstGeom prst="rect">
+            <a:avLst/>
+          </a:prstGeom>
+          <a:solidFill>
+            <a:srgbClr val="FF8C00"/>
           </a:solidFill>
           <a:ln>
             <a:noFill/>
@@ -4166,8 +4166,8 @@
         </p:nvSpPr>
         <p:spPr>
           <a:xfrm>
-            <a:off x="758952" y="4087368"/>
-            <a:ext cx="3291840" cy="1920240"/>
+            <a:off x="795528" y="4087368"/>
+            <a:ext cx="3246120" cy="1920240"/>
           </a:xfrm>
           <a:prstGeom prst="rect">
             <a:avLst/>
@@ -4188,7 +4188,7 @@
                 <a:cs typeface="Calibri"/>
                 <a:ea typeface="Calibri"/>
                 <a:solidFill>
-                  <a:srgbClr val="FFFFFF"/>
+                  <a:srgbClr val="0B3D6E"/>
                 </a:solidFill>
                 <a:latin typeface="Calibri"/>
               </a:rPr>
@@ -4206,7 +4206,7 @@
                 <a:cs typeface="Calibri"/>
                 <a:ea typeface="Calibri"/>
                 <a:solidFill>
-                  <a:srgbClr val="9AB0C6"/>
+                  <a:srgbClr val="3D556B"/>
                 </a:solidFill>
                 <a:latin typeface="Calibri"/>
               </a:rPr>
@@ -4231,11 +4231,11 @@
             <a:avLst/>
           </a:prstGeom>
           <a:solidFill>
-            <a:srgbClr val="162A44"/>
-          </a:solidFill>
-          <a:ln>
+            <a:srgbClr val="FFFFFF"/>
+          </a:solidFill>
+          <a:ln w="28575">
             <a:solidFill>
-              <a:srgbClr val="2A405C"/>
+              <a:srgbClr val="009EE0"/>
             </a:solidFill>
           </a:ln>
         </p:spPr>
@@ -4270,13 +4270,13 @@
         <p:spPr>
           <a:xfrm>
             <a:off x="4343400" y="3886200"/>
-            <a:ext cx="91440" cy="2240280"/>
-          </a:xfrm>
-          <a:prstGeom prst="rect">
-            <a:avLst/>
-          </a:prstGeom>
-          <a:solidFill>
-            <a:srgbClr val="2ED3B7"/>
+            <a:ext cx="128016" cy="2240280"/>
+          </a:xfrm>
+          <a:prstGeom prst="rect">
+            <a:avLst/>
+          </a:prstGeom>
+          <a:solidFill>
+            <a:srgbClr val="009EE0"/>
           </a:solidFill>
           <a:ln>
             <a:noFill/>
@@ -4312,8 +4312,8 @@
         </p:nvSpPr>
         <p:spPr>
           <a:xfrm>
-            <a:off x="4599432" y="4087368"/>
-            <a:ext cx="3291840" cy="1920240"/>
+            <a:off x="4636008" y="4087368"/>
+            <a:ext cx="3246120" cy="1920240"/>
           </a:xfrm>
           <a:prstGeom prst="rect">
             <a:avLst/>
@@ -4334,7 +4334,7 @@
                 <a:cs typeface="Calibri"/>
                 <a:ea typeface="Calibri"/>
                 <a:solidFill>
-                  <a:srgbClr val="FFFFFF"/>
+                  <a:srgbClr val="0B3D6E"/>
                 </a:solidFill>
                 <a:latin typeface="Calibri"/>
               </a:rPr>
@@ -4352,7 +4352,7 @@
                 <a:cs typeface="Calibri"/>
                 <a:ea typeface="Calibri"/>
                 <a:solidFill>
-                  <a:srgbClr val="9AB0C6"/>
+                  <a:srgbClr val="3D556B"/>
                 </a:solidFill>
                 <a:latin typeface="Calibri"/>
               </a:rPr>
@@ -4377,11 +4377,11 @@
             <a:avLst/>
           </a:prstGeom>
           <a:solidFill>
-            <a:srgbClr val="162A44"/>
-          </a:solidFill>
-          <a:ln>
+            <a:srgbClr val="FFFFFF"/>
+          </a:solidFill>
+          <a:ln w="28575">
             <a:solidFill>
-              <a:srgbClr val="2A405C"/>
+              <a:srgbClr val="009EE0"/>
             </a:solidFill>
           </a:ln>
         </p:spPr>
@@ -4416,13 +4416,13 @@
         <p:spPr>
           <a:xfrm>
             <a:off x="8183880" y="3886200"/>
-            <a:ext cx="91440" cy="2240280"/>
-          </a:xfrm>
-          <a:prstGeom prst="rect">
-            <a:avLst/>
-          </a:prstGeom>
-          <a:solidFill>
-            <a:srgbClr val="2ED3B7"/>
+            <a:ext cx="128016" cy="2240280"/>
+          </a:xfrm>
+          <a:prstGeom prst="rect">
+            <a:avLst/>
+          </a:prstGeom>
+          <a:solidFill>
+            <a:srgbClr val="009EE0"/>
           </a:solidFill>
           <a:ln>
             <a:noFill/>
@@ -4458,8 +4458,8 @@
         </p:nvSpPr>
         <p:spPr>
           <a:xfrm>
-            <a:off x="8439912" y="4087368"/>
-            <a:ext cx="3291840" cy="1920240"/>
+            <a:off x="8476488" y="4087368"/>
+            <a:ext cx="3246120" cy="1920240"/>
           </a:xfrm>
           <a:prstGeom prst="rect">
             <a:avLst/>
@@ -4480,7 +4480,7 @@
                 <a:cs typeface="Calibri"/>
                 <a:ea typeface="Calibri"/>
                 <a:solidFill>
-                  <a:srgbClr val="FFFFFF"/>
+                  <a:srgbClr val="0B3D6E"/>
                 </a:solidFill>
                 <a:latin typeface="Calibri"/>
               </a:rPr>
@@ -4498,7 +4498,7 @@
                 <a:cs typeface="Calibri"/>
                 <a:ea typeface="Calibri"/>
                 <a:solidFill>
-                  <a:srgbClr val="9AB0C6"/>
+                  <a:srgbClr val="3D556B"/>
                 </a:solidFill>
                 <a:latin typeface="Calibri"/>
               </a:rPr>
@@ -4541,7 +4541,7 @@
             <a:avLst/>
           </a:prstGeom>
           <a:solidFill>
-            <a:srgbClr val="0B1422"/>
+            <a:srgbClr val="EFF8FF"/>
           </a:solidFill>
           <a:ln>
             <a:noFill/>
@@ -4584,7 +4584,7 @@
             <a:avLst/>
           </a:prstGeom>
           <a:solidFill>
-            <a:srgbClr val="2ED3B7"/>
+            <a:srgbClr val="009EE0"/>
           </a:solidFill>
           <a:ln>
             <a:noFill/>
@@ -4642,7 +4642,7 @@
                 <a:cs typeface="Calibri"/>
                 <a:ea typeface="Calibri"/>
                 <a:solidFill>
-                  <a:srgbClr val="2ED3B7"/>
+                  <a:srgbClr val="009EE0"/>
                 </a:solidFill>
                 <a:latin typeface="Calibri"/>
               </a:rPr>
@@ -4660,7 +4660,7 @@
                 <a:cs typeface="Calibri"/>
                 <a:ea typeface="Calibri"/>
                 <a:solidFill>
-                  <a:srgbClr val="FFFFFF"/>
+                  <a:srgbClr val="0B3D6E"/>
                 </a:solidFill>
                 <a:latin typeface="Calibri"/>
               </a:rPr>
@@ -4684,11 +4684,11 @@
             <a:avLst/>
           </a:prstGeom>
           <a:solidFill>
-            <a:srgbClr val="162A44"/>
+            <a:srgbClr val="FFFFFF"/>
           </a:solidFill>
           <a:ln>
             <a:solidFill>
-              <a:srgbClr val="2A405C"/>
+              <a:srgbClr val="B8D4EA"/>
             </a:solidFill>
           </a:ln>
         </p:spPr>
@@ -4729,7 +4729,7 @@
             <a:avLst/>
           </a:prstGeom>
           <a:solidFill>
-            <a:srgbClr val="2ED3B7"/>
+            <a:srgbClr val="009EE0"/>
           </a:solidFill>
           <a:ln>
             <a:noFill/>
@@ -4787,7 +4787,7 @@
                 <a:cs typeface="Calibri"/>
                 <a:ea typeface="Calibri"/>
                 <a:solidFill>
-                  <a:srgbClr val="0B1422"/>
+                  <a:srgbClr val="FFFFFF"/>
                 </a:solidFill>
                 <a:latin typeface="Calibri"/>
               </a:rPr>
@@ -4826,7 +4826,7 @@
                 <a:cs typeface="Calibri"/>
                 <a:ea typeface="Calibri"/>
                 <a:solidFill>
-                  <a:srgbClr val="9AB0C6"/>
+                  <a:srgbClr val="3D556B"/>
                 </a:solidFill>
                 <a:latin typeface="Calibri"/>
               </a:rPr>
@@ -4852,11 +4852,11 @@
             <a:avLst/>
           </a:prstGeom>
           <a:solidFill>
-            <a:srgbClr val="162A44"/>
+            <a:srgbClr val="FFFFFF"/>
           </a:solidFill>
           <a:ln>
             <a:solidFill>
-              <a:srgbClr val="2A405C"/>
+              <a:srgbClr val="B8D4EA"/>
             </a:solidFill>
           </a:ln>
         </p:spPr>
@@ -4897,7 +4897,7 @@
             <a:avLst/>
           </a:prstGeom>
           <a:solidFill>
-            <a:srgbClr val="F5B32E"/>
+            <a:srgbClr val="FF8C00"/>
           </a:solidFill>
           <a:ln>
             <a:noFill/>
@@ -4955,7 +4955,7 @@
                 <a:cs typeface="Calibri"/>
                 <a:ea typeface="Calibri"/>
                 <a:solidFill>
-                  <a:srgbClr val="0B1422"/>
+                  <a:srgbClr val="FFFFFF"/>
                 </a:solidFill>
                 <a:latin typeface="Calibri"/>
               </a:rPr>
@@ -4994,7 +4994,7 @@
                 <a:cs typeface="Calibri"/>
                 <a:ea typeface="Calibri"/>
                 <a:solidFill>
-                  <a:srgbClr val="9AB0C6"/>
+                  <a:srgbClr val="3D556B"/>
                 </a:solidFill>
                 <a:latin typeface="Calibri"/>
               </a:rPr>
@@ -5020,11 +5020,11 @@
             <a:avLst/>
           </a:prstGeom>
           <a:solidFill>
-            <a:srgbClr val="162A44"/>
+            <a:srgbClr val="FFFFFF"/>
           </a:solidFill>
           <a:ln>
             <a:solidFill>
-              <a:srgbClr val="2A405C"/>
+              <a:srgbClr val="B8D4EA"/>
             </a:solidFill>
           </a:ln>
         </p:spPr>
@@ -5065,7 +5065,7 @@
             <a:avLst/>
           </a:prstGeom>
           <a:solidFill>
-            <a:srgbClr val="FF6B6B"/>
+            <a:srgbClr val="FF3D6E"/>
           </a:solidFill>
           <a:ln>
             <a:noFill/>
@@ -5123,7 +5123,7 @@
                 <a:cs typeface="Calibri"/>
                 <a:ea typeface="Calibri"/>
                 <a:solidFill>
-                  <a:srgbClr val="0B1422"/>
+                  <a:srgbClr val="FFFFFF"/>
                 </a:solidFill>
                 <a:latin typeface="Calibri"/>
               </a:rPr>
@@ -5162,7 +5162,7 @@
                 <a:cs typeface="Calibri"/>
                 <a:ea typeface="Calibri"/>
                 <a:solidFill>
-                  <a:srgbClr val="9AB0C6"/>
+                  <a:srgbClr val="3D556B"/>
                 </a:solidFill>
                 <a:latin typeface="Calibri"/>
               </a:rPr>
@@ -5206,7 +5206,7 @@
             <a:avLst/>
           </a:prstGeom>
           <a:solidFill>
-            <a:srgbClr val="0B1422"/>
+            <a:srgbClr val="EFF8FF"/>
           </a:solidFill>
           <a:ln>
             <a:noFill/>
@@ -5249,7 +5249,7 @@
             <a:avLst/>
           </a:prstGeom>
           <a:solidFill>
-            <a:srgbClr val="2ED3B7"/>
+            <a:srgbClr val="009EE0"/>
           </a:solidFill>
           <a:ln>
             <a:noFill/>
@@ -5307,7 +5307,7 @@
                 <a:cs typeface="Calibri"/>
                 <a:ea typeface="Calibri"/>
                 <a:solidFill>
-                  <a:srgbClr val="F5B32E"/>
+                  <a:srgbClr val="FF8C00"/>
                 </a:solidFill>
                 <a:latin typeface="Calibri"/>
               </a:rPr>
@@ -5325,7 +5325,7 @@
                 <a:cs typeface="Calibri"/>
                 <a:ea typeface="Calibri"/>
                 <a:solidFill>
-                  <a:srgbClr val="FFFFFF"/>
+                  <a:srgbClr val="0B3D6E"/>
                 </a:solidFill>
                 <a:latin typeface="Calibri"/>
               </a:rPr>
@@ -5349,11 +5349,11 @@
             <a:avLst/>
           </a:prstGeom>
           <a:solidFill>
-            <a:srgbClr val="162A44"/>
-          </a:solidFill>
-          <a:ln>
+            <a:srgbClr val="FFFFFF"/>
+          </a:solidFill>
+          <a:ln w="28575">
             <a:solidFill>
-              <a:srgbClr val="2A405C"/>
+              <a:srgbClr val="FF8C00"/>
             </a:solidFill>
           </a:ln>
         </p:spPr>
@@ -5388,13 +5388,13 @@
         <p:spPr>
           <a:xfrm>
             <a:off x="502920" y="1463040"/>
-            <a:ext cx="91440" cy="2148840"/>
-          </a:xfrm>
-          <a:prstGeom prst="rect">
-            <a:avLst/>
-          </a:prstGeom>
-          <a:solidFill>
-            <a:srgbClr val="F5B32E"/>
+            <a:ext cx="128016" cy="2148840"/>
+          </a:xfrm>
+          <a:prstGeom prst="rect">
+            <a:avLst/>
+          </a:prstGeom>
+          <a:solidFill>
+            <a:srgbClr val="FF8C00"/>
           </a:solidFill>
           <a:ln>
             <a:noFill/>
@@ -5430,8 +5430,8 @@
         </p:nvSpPr>
         <p:spPr>
           <a:xfrm>
-            <a:off x="758952" y="1664208"/>
-            <a:ext cx="3291840" cy="1828800"/>
+            <a:off x="795528" y="1664208"/>
+            <a:ext cx="3246120" cy="1828800"/>
           </a:xfrm>
           <a:prstGeom prst="rect">
             <a:avLst/>
@@ -5452,7 +5452,7 @@
                 <a:cs typeface="Calibri"/>
                 <a:ea typeface="Calibri"/>
                 <a:solidFill>
-                  <a:srgbClr val="FFFFFF"/>
+                  <a:srgbClr val="0B3D6E"/>
                 </a:solidFill>
                 <a:latin typeface="Calibri"/>
               </a:rPr>
@@ -5470,7 +5470,7 @@
                 <a:cs typeface="Calibri"/>
                 <a:ea typeface="Calibri"/>
                 <a:solidFill>
-                  <a:srgbClr val="9AB0C6"/>
+                  <a:srgbClr val="3D556B"/>
                 </a:solidFill>
                 <a:latin typeface="Calibri"/>
               </a:rPr>
@@ -5494,11 +5494,11 @@
             <a:avLst/>
           </a:prstGeom>
           <a:solidFill>
-            <a:srgbClr val="162A44"/>
-          </a:solidFill>
-          <a:ln>
+            <a:srgbClr val="FFFFFF"/>
+          </a:solidFill>
+          <a:ln w="28575">
             <a:solidFill>
-              <a:srgbClr val="2A405C"/>
+              <a:srgbClr val="FF8C00"/>
             </a:solidFill>
           </a:ln>
         </p:spPr>
@@ -5533,13 +5533,13 @@
         <p:spPr>
           <a:xfrm>
             <a:off x="4343400" y="1463040"/>
-            <a:ext cx="91440" cy="2148840"/>
-          </a:xfrm>
-          <a:prstGeom prst="rect">
-            <a:avLst/>
-          </a:prstGeom>
-          <a:solidFill>
-            <a:srgbClr val="F5B32E"/>
+            <a:ext cx="128016" cy="2148840"/>
+          </a:xfrm>
+          <a:prstGeom prst="rect">
+            <a:avLst/>
+          </a:prstGeom>
+          <a:solidFill>
+            <a:srgbClr val="FF8C00"/>
           </a:solidFill>
           <a:ln>
             <a:noFill/>
@@ -5575,8 +5575,8 @@
         </p:nvSpPr>
         <p:spPr>
           <a:xfrm>
-            <a:off x="4599432" y="1664208"/>
-            <a:ext cx="3291840" cy="1828800"/>
+            <a:off x="4636008" y="1664208"/>
+            <a:ext cx="3246120" cy="1828800"/>
           </a:xfrm>
           <a:prstGeom prst="rect">
             <a:avLst/>
@@ -5597,7 +5597,7 @@
                 <a:cs typeface="Calibri"/>
                 <a:ea typeface="Calibri"/>
                 <a:solidFill>
-                  <a:srgbClr val="FFFFFF"/>
+                  <a:srgbClr val="0B3D6E"/>
                 </a:solidFill>
                 <a:latin typeface="Calibri"/>
               </a:rPr>
@@ -5615,7 +5615,7 @@
                 <a:cs typeface="Calibri"/>
                 <a:ea typeface="Calibri"/>
                 <a:solidFill>
-                  <a:srgbClr val="9AB0C6"/>
+                  <a:srgbClr val="3D556B"/>
                 </a:solidFill>
                 <a:latin typeface="Calibri"/>
               </a:rPr>
@@ -5639,11 +5639,11 @@
             <a:avLst/>
           </a:prstGeom>
           <a:solidFill>
-            <a:srgbClr val="162A44"/>
-          </a:solidFill>
-          <a:ln>
+            <a:srgbClr val="FFFFFF"/>
+          </a:solidFill>
+          <a:ln w="28575">
             <a:solidFill>
-              <a:srgbClr val="2A405C"/>
+              <a:srgbClr val="FF8C00"/>
             </a:solidFill>
           </a:ln>
         </p:spPr>
@@ -5678,13 +5678,13 @@
         <p:spPr>
           <a:xfrm>
             <a:off x="8183880" y="1463040"/>
-            <a:ext cx="91440" cy="2148840"/>
-          </a:xfrm>
-          <a:prstGeom prst="rect">
-            <a:avLst/>
-          </a:prstGeom>
-          <a:solidFill>
-            <a:srgbClr val="F5B32E"/>
+            <a:ext cx="128016" cy="2148840"/>
+          </a:xfrm>
+          <a:prstGeom prst="rect">
+            <a:avLst/>
+          </a:prstGeom>
+          <a:solidFill>
+            <a:srgbClr val="FF8C00"/>
           </a:solidFill>
           <a:ln>
             <a:noFill/>
@@ -5720,8 +5720,8 @@
         </p:nvSpPr>
         <p:spPr>
           <a:xfrm>
-            <a:off x="8439912" y="1664208"/>
-            <a:ext cx="3291840" cy="1828800"/>
+            <a:off x="8476488" y="1664208"/>
+            <a:ext cx="3246120" cy="1828800"/>
           </a:xfrm>
           <a:prstGeom prst="rect">
             <a:avLst/>
@@ -5742,7 +5742,7 @@
                 <a:cs typeface="Calibri"/>
                 <a:ea typeface="Calibri"/>
                 <a:solidFill>
-                  <a:srgbClr val="FFFFFF"/>
+                  <a:srgbClr val="0B3D6E"/>
                 </a:solidFill>
                 <a:latin typeface="Calibri"/>
               </a:rPr>
@@ -5760,7 +5760,7 @@
                 <a:cs typeface="Calibri"/>
                 <a:ea typeface="Calibri"/>
                 <a:solidFill>
-                  <a:srgbClr val="9AB0C6"/>
+                  <a:srgbClr val="3D556B"/>
                 </a:solidFill>
                 <a:latin typeface="Calibri"/>
               </a:rPr>
@@ -5784,11 +5784,11 @@
             <a:avLst/>
           </a:prstGeom>
           <a:solidFill>
-            <a:srgbClr val="162A44"/>
-          </a:solidFill>
-          <a:ln>
+            <a:srgbClr val="FFFFFF"/>
+          </a:solidFill>
+          <a:ln w="28575">
             <a:solidFill>
-              <a:srgbClr val="2A405C"/>
+              <a:srgbClr val="009EE0"/>
             </a:solidFill>
           </a:ln>
         </p:spPr>
@@ -5823,13 +5823,13 @@
         <p:spPr>
           <a:xfrm>
             <a:off x="502920" y="3794760"/>
-            <a:ext cx="91440" cy="2148840"/>
-          </a:xfrm>
-          <a:prstGeom prst="rect">
-            <a:avLst/>
-          </a:prstGeom>
-          <a:solidFill>
-            <a:srgbClr val="2ED3B7"/>
+            <a:ext cx="128016" cy="2148840"/>
+          </a:xfrm>
+          <a:prstGeom prst="rect">
+            <a:avLst/>
+          </a:prstGeom>
+          <a:solidFill>
+            <a:srgbClr val="009EE0"/>
           </a:solidFill>
           <a:ln>
             <a:noFill/>
@@ -5865,8 +5865,8 @@
         </p:nvSpPr>
         <p:spPr>
           <a:xfrm>
-            <a:off x="758952" y="3995928"/>
-            <a:ext cx="3291840" cy="1828800"/>
+            <a:off x="795528" y="3995928"/>
+            <a:ext cx="3246120" cy="1828800"/>
           </a:xfrm>
           <a:prstGeom prst="rect">
             <a:avLst/>
@@ -5887,7 +5887,7 @@
                 <a:cs typeface="Calibri"/>
                 <a:ea typeface="Calibri"/>
                 <a:solidFill>
-                  <a:srgbClr val="FFFFFF"/>
+                  <a:srgbClr val="0B3D6E"/>
                 </a:solidFill>
                 <a:latin typeface="Calibri"/>
               </a:rPr>
@@ -5905,7 +5905,7 @@
                 <a:cs typeface="Calibri"/>
                 <a:ea typeface="Calibri"/>
                 <a:solidFill>
-                  <a:srgbClr val="9AB0C6"/>
+                  <a:srgbClr val="3D556B"/>
                 </a:solidFill>
                 <a:latin typeface="Calibri"/>
               </a:rPr>
@@ -5929,11 +5929,11 @@
             <a:avLst/>
           </a:prstGeom>
           <a:solidFill>
-            <a:srgbClr val="162A44"/>
-          </a:solidFill>
-          <a:ln>
+            <a:srgbClr val="FFFFFF"/>
+          </a:solidFill>
+          <a:ln w="28575">
             <a:solidFill>
-              <a:srgbClr val="2A405C"/>
+              <a:srgbClr val="009EE0"/>
             </a:solidFill>
           </a:ln>
         </p:spPr>
@@ -5968,13 +5968,13 @@
         <p:spPr>
           <a:xfrm>
             <a:off x="4343400" y="3794760"/>
-            <a:ext cx="91440" cy="2148840"/>
-          </a:xfrm>
-          <a:prstGeom prst="rect">
-            <a:avLst/>
-          </a:prstGeom>
-          <a:solidFill>
-            <a:srgbClr val="2ED3B7"/>
+            <a:ext cx="128016" cy="2148840"/>
+          </a:xfrm>
+          <a:prstGeom prst="rect">
+            <a:avLst/>
+          </a:prstGeom>
+          <a:solidFill>
+            <a:srgbClr val="009EE0"/>
           </a:solidFill>
           <a:ln>
             <a:noFill/>
@@ -6010,8 +6010,8 @@
         </p:nvSpPr>
         <p:spPr>
           <a:xfrm>
-            <a:off x="4599432" y="3995928"/>
-            <a:ext cx="3291840" cy="1828800"/>
+            <a:off x="4636008" y="3995928"/>
+            <a:ext cx="3246120" cy="1828800"/>
           </a:xfrm>
           <a:prstGeom prst="rect">
             <a:avLst/>
@@ -6032,7 +6032,7 @@
                 <a:cs typeface="Calibri"/>
                 <a:ea typeface="Calibri"/>
                 <a:solidFill>
-                  <a:srgbClr val="FFFFFF"/>
+                  <a:srgbClr val="0B3D6E"/>
                 </a:solidFill>
                 <a:latin typeface="Calibri"/>
               </a:rPr>
@@ -6050,7 +6050,7 @@
                 <a:cs typeface="Calibri"/>
                 <a:ea typeface="Calibri"/>
                 <a:solidFill>
-                  <a:srgbClr val="9AB0C6"/>
+                  <a:srgbClr val="3D556B"/>
                 </a:solidFill>
                 <a:latin typeface="Calibri"/>
               </a:rPr>
@@ -6074,11 +6074,11 @@
             <a:avLst/>
           </a:prstGeom>
           <a:solidFill>
-            <a:srgbClr val="162A44"/>
-          </a:solidFill>
-          <a:ln>
+            <a:srgbClr val="FFFFFF"/>
+          </a:solidFill>
+          <a:ln w="28575">
             <a:solidFill>
-              <a:srgbClr val="2A405C"/>
+              <a:srgbClr val="009EE0"/>
             </a:solidFill>
           </a:ln>
         </p:spPr>
@@ -6113,13 +6113,13 @@
         <p:spPr>
           <a:xfrm>
             <a:off x="8183880" y="3794760"/>
-            <a:ext cx="91440" cy="2148840"/>
-          </a:xfrm>
-          <a:prstGeom prst="rect">
-            <a:avLst/>
-          </a:prstGeom>
-          <a:solidFill>
-            <a:srgbClr val="2ED3B7"/>
+            <a:ext cx="128016" cy="2148840"/>
+          </a:xfrm>
+          <a:prstGeom prst="rect">
+            <a:avLst/>
+          </a:prstGeom>
+          <a:solidFill>
+            <a:srgbClr val="009EE0"/>
           </a:solidFill>
           <a:ln>
             <a:noFill/>
@@ -6155,8 +6155,8 @@
         </p:nvSpPr>
         <p:spPr>
           <a:xfrm>
-            <a:off x="8439912" y="3995928"/>
-            <a:ext cx="3291840" cy="1828800"/>
+            <a:off x="8476488" y="3995928"/>
+            <a:ext cx="3246120" cy="1828800"/>
           </a:xfrm>
           <a:prstGeom prst="rect">
             <a:avLst/>
@@ -6177,7 +6177,7 @@
                 <a:cs typeface="Calibri"/>
                 <a:ea typeface="Calibri"/>
                 <a:solidFill>
-                  <a:srgbClr val="FFFFFF"/>
+                  <a:srgbClr val="0B3D6E"/>
                 </a:solidFill>
                 <a:latin typeface="Calibri"/>
               </a:rPr>
@@ -6195,7 +6195,7 @@
                 <a:cs typeface="Calibri"/>
                 <a:ea typeface="Calibri"/>
                 <a:solidFill>
-                  <a:srgbClr val="9AB0C6"/>
+                  <a:srgbClr val="3D556B"/>
                 </a:solidFill>
                 <a:latin typeface="Calibri"/>
               </a:rPr>
@@ -6237,7 +6237,7 @@
             <a:avLst/>
           </a:prstGeom>
           <a:solidFill>
-            <a:srgbClr val="0B1422"/>
+            <a:srgbClr val="EFF8FF"/>
           </a:solidFill>
           <a:ln>
             <a:noFill/>
@@ -6280,7 +6280,7 @@
             <a:avLst/>
           </a:prstGeom>
           <a:solidFill>
-            <a:srgbClr val="2ED3B7"/>
+            <a:srgbClr val="009EE0"/>
           </a:solidFill>
           <a:ln>
             <a:noFill/>
@@ -6338,7 +6338,7 @@
                 <a:cs typeface="Calibri"/>
                 <a:ea typeface="Calibri"/>
                 <a:solidFill>
-                  <a:srgbClr val="2ED3B7"/>
+                  <a:srgbClr val="009EE0"/>
                 </a:solidFill>
                 <a:latin typeface="Calibri"/>
               </a:rPr>
@@ -6356,7 +6356,7 @@
                 <a:cs typeface="Calibri"/>
                 <a:ea typeface="Calibri"/>
                 <a:solidFill>
-                  <a:srgbClr val="FFFFFF"/>
+                  <a:srgbClr val="0B3D6E"/>
                 </a:solidFill>
                 <a:latin typeface="Calibri"/>
               </a:rPr>
@@ -6380,11 +6380,11 @@
             <a:avLst/>
           </a:prstGeom>
           <a:solidFill>
-            <a:srgbClr val="162A44"/>
+            <a:srgbClr val="FFFFFF"/>
           </a:solidFill>
           <a:ln>
             <a:solidFill>
-              <a:srgbClr val="2A405C"/>
+              <a:srgbClr val="B8D4EA"/>
             </a:solidFill>
           </a:ln>
         </p:spPr>
@@ -6425,7 +6425,7 @@
             <a:avLst/>
           </a:prstGeom>
           <a:solidFill>
-            <a:srgbClr val="F5B32E"/>
+            <a:srgbClr val="FF8C00"/>
           </a:solidFill>
           <a:ln>
             <a:noFill/>
@@ -6483,7 +6483,7 @@
                 <a:cs typeface="Calibri"/>
                 <a:ea typeface="Calibri"/>
                 <a:solidFill>
-                  <a:srgbClr val="FFFFFF"/>
+                  <a:srgbClr val="0B3D6E"/>
                 </a:solidFill>
                 <a:latin typeface="Calibri"/>
               </a:rPr>
@@ -6522,7 +6522,7 @@
                 <a:cs typeface="Calibri"/>
                 <a:ea typeface="Calibri"/>
                 <a:solidFill>
-                  <a:srgbClr val="9AB0C6"/>
+                  <a:srgbClr val="3D556B"/>
                 </a:solidFill>
                 <a:latin typeface="Calibri"/>
               </a:rPr>
@@ -6540,7 +6540,7 @@
                 <a:cs typeface="Calibri"/>
                 <a:ea typeface="Calibri"/>
                 <a:solidFill>
-                  <a:srgbClr val="F2F6FB"/>
+                  <a:srgbClr val="0F1F2E"/>
                 </a:solidFill>
                 <a:latin typeface="Calibri"/>
               </a:rPr>
@@ -6579,7 +6579,7 @@
                 <a:cs typeface="Calibri"/>
                 <a:ea typeface="Calibri"/>
                 <a:solidFill>
-                  <a:srgbClr val="9AB0C6"/>
+                  <a:srgbClr val="3D556B"/>
                 </a:solidFill>
                 <a:latin typeface="Calibri"/>
               </a:rPr>
@@ -6597,7 +6597,7 @@
                 <a:cs typeface="Calibri"/>
                 <a:ea typeface="Calibri"/>
                 <a:solidFill>
-                  <a:srgbClr val="F2F6FB"/>
+                  <a:srgbClr val="0F1F2E"/>
                 </a:solidFill>
                 <a:latin typeface="Calibri"/>
               </a:rPr>
@@ -6621,11 +6621,11 @@
             <a:avLst/>
           </a:prstGeom>
           <a:solidFill>
-            <a:srgbClr val="162A44"/>
+            <a:srgbClr val="FFFFFF"/>
           </a:solidFill>
           <a:ln>
             <a:solidFill>
-              <a:srgbClr val="2A405C"/>
+              <a:srgbClr val="B8D4EA"/>
             </a:solidFill>
           </a:ln>
         </p:spPr>
@@ -6666,7 +6666,7 @@
             <a:avLst/>
           </a:prstGeom>
           <a:solidFill>
-            <a:srgbClr val="2ED3B7"/>
+            <a:srgbClr val="009EE0"/>
           </a:solidFill>
           <a:ln>
             <a:noFill/>
@@ -6724,7 +6724,7 @@
                 <a:cs typeface="Calibri"/>
                 <a:ea typeface="Calibri"/>
                 <a:solidFill>
-                  <a:srgbClr val="FFFFFF"/>
+                  <a:srgbClr val="0B3D6E"/>
                 </a:solidFill>
                 <a:latin typeface="Calibri"/>
               </a:rPr>
@@ -6763,7 +6763,7 @@
                 <a:cs typeface="Calibri"/>
                 <a:ea typeface="Calibri"/>
                 <a:solidFill>
-                  <a:srgbClr val="9AB0C6"/>
+                  <a:srgbClr val="3D556B"/>
                 </a:solidFill>
                 <a:latin typeface="Calibri"/>
               </a:rPr>
@@ -6781,7 +6781,7 @@
                 <a:cs typeface="Calibri"/>
                 <a:ea typeface="Calibri"/>
                 <a:solidFill>
-                  <a:srgbClr val="F2F6FB"/>
+                  <a:srgbClr val="0F1F2E"/>
                 </a:solidFill>
                 <a:latin typeface="Calibri"/>
               </a:rPr>
@@ -6820,7 +6820,7 @@
                 <a:cs typeface="Calibri"/>
                 <a:ea typeface="Calibri"/>
                 <a:solidFill>
-                  <a:srgbClr val="9AB0C6"/>
+                  <a:srgbClr val="3D556B"/>
                 </a:solidFill>
                 <a:latin typeface="Calibri"/>
               </a:rPr>
@@ -6838,7 +6838,7 @@
                 <a:cs typeface="Calibri"/>
                 <a:ea typeface="Calibri"/>
                 <a:solidFill>
-                  <a:srgbClr val="F2F6FB"/>
+                  <a:srgbClr val="0F1F2E"/>
                 </a:solidFill>
                 <a:latin typeface="Calibri"/>
               </a:rPr>
@@ -6862,11 +6862,11 @@
             <a:avLst/>
           </a:prstGeom>
           <a:solidFill>
-            <a:srgbClr val="162A44"/>
+            <a:srgbClr val="FFFFFF"/>
           </a:solidFill>
           <a:ln>
             <a:solidFill>
-              <a:srgbClr val="2A405C"/>
+              <a:srgbClr val="B8D4EA"/>
             </a:solidFill>
           </a:ln>
         </p:spPr>
@@ -6907,7 +6907,7 @@
             <a:avLst/>
           </a:prstGeom>
           <a:solidFill>
-            <a:srgbClr val="FF6B6B"/>
+            <a:srgbClr val="FF3D6E"/>
           </a:solidFill>
           <a:ln>
             <a:noFill/>
@@ -6965,7 +6965,7 @@
                 <a:cs typeface="Calibri"/>
                 <a:ea typeface="Calibri"/>
                 <a:solidFill>
-                  <a:srgbClr val="FFFFFF"/>
+                  <a:srgbClr val="0B3D6E"/>
                 </a:solidFill>
                 <a:latin typeface="Calibri"/>
               </a:rPr>
@@ -7004,7 +7004,7 @@
                 <a:cs typeface="Calibri"/>
                 <a:ea typeface="Calibri"/>
                 <a:solidFill>
-                  <a:srgbClr val="9AB0C6"/>
+                  <a:srgbClr val="3D556B"/>
                 </a:solidFill>
                 <a:latin typeface="Calibri"/>
               </a:rPr>
@@ -7022,7 +7022,7 @@
                 <a:cs typeface="Calibri"/>
                 <a:ea typeface="Calibri"/>
                 <a:solidFill>
-                  <a:srgbClr val="F2F6FB"/>
+                  <a:srgbClr val="0F1F2E"/>
                 </a:solidFill>
                 <a:latin typeface="Calibri"/>
               </a:rPr>
@@ -7061,7 +7061,7 @@
                 <a:cs typeface="Calibri"/>
                 <a:ea typeface="Calibri"/>
                 <a:solidFill>
-                  <a:srgbClr val="9AB0C6"/>
+                  <a:srgbClr val="3D556B"/>
                 </a:solidFill>
                 <a:latin typeface="Calibri"/>
               </a:rPr>
@@ -7079,7 +7079,7 @@
                 <a:cs typeface="Calibri"/>
                 <a:ea typeface="Calibri"/>
                 <a:solidFill>
-                  <a:srgbClr val="F2F6FB"/>
+                  <a:srgbClr val="0F1F2E"/>
                 </a:solidFill>
                 <a:latin typeface="Calibri"/>
               </a:rPr>
@@ -7121,7 +7121,7 @@
             <a:avLst/>
           </a:prstGeom>
           <a:solidFill>
-            <a:srgbClr val="0B1422"/>
+            <a:srgbClr val="EFF8FF"/>
           </a:solidFill>
           <a:ln>
             <a:noFill/>
@@ -7164,7 +7164,7 @@
             <a:avLst/>
           </a:prstGeom>
           <a:solidFill>
-            <a:srgbClr val="2ED3B7"/>
+            <a:srgbClr val="009EE0"/>
           </a:solidFill>
           <a:ln>
             <a:noFill/>
@@ -7222,7 +7222,7 @@
                 <a:cs typeface="Calibri"/>
                 <a:ea typeface="Calibri"/>
                 <a:solidFill>
-                  <a:srgbClr val="2ED3B7"/>
+                  <a:srgbClr val="009EE0"/>
                 </a:solidFill>
                 <a:latin typeface="Calibri"/>
               </a:rPr>
@@ -7240,7 +7240,7 @@
                 <a:cs typeface="Calibri"/>
                 <a:ea typeface="Calibri"/>
                 <a:solidFill>
-                  <a:srgbClr val="FFFFFF"/>
+                  <a:srgbClr val="0B3D6E"/>
                 </a:solidFill>
                 <a:latin typeface="Calibri"/>
               </a:rPr>
@@ -7264,11 +7264,11 @@
             <a:avLst/>
           </a:prstGeom>
           <a:solidFill>
-            <a:srgbClr val="162A44"/>
+            <a:srgbClr val="FFFFFF"/>
           </a:solidFill>
           <a:ln>
             <a:solidFill>
-              <a:srgbClr val="2A405C"/>
+              <a:srgbClr val="B8D4EA"/>
             </a:solidFill>
           </a:ln>
         </p:spPr>
@@ -7324,7 +7324,7 @@
                 <a:cs typeface="Calibri"/>
                 <a:ea typeface="Calibri"/>
                 <a:solidFill>
-                  <a:srgbClr val="FFFFFF"/>
+                  <a:srgbClr val="0B3D6E"/>
                 </a:solidFill>
                 <a:latin typeface="Calibri"/>
               </a:rPr>
@@ -7342,7 +7342,7 @@
                 <a:cs typeface="Calibri"/>
                 <a:ea typeface="Calibri"/>
                 <a:solidFill>
-                  <a:srgbClr val="F5B32E"/>
+                  <a:srgbClr val="FF8C00"/>
                 </a:solidFill>
                 <a:latin typeface="Calibri"/>
               </a:rPr>
@@ -7366,11 +7366,11 @@
             <a:avLst/>
           </a:prstGeom>
           <a:solidFill>
-            <a:srgbClr val="162A44"/>
+            <a:srgbClr val="FFFFFF"/>
           </a:solidFill>
           <a:ln>
             <a:solidFill>
-              <a:srgbClr val="2A405C"/>
+              <a:srgbClr val="B8D4EA"/>
             </a:solidFill>
           </a:ln>
         </p:spPr>
@@ -7426,7 +7426,7 @@
                 <a:cs typeface="Calibri"/>
                 <a:ea typeface="Calibri"/>
                 <a:solidFill>
-                  <a:srgbClr val="FFFFFF"/>
+                  <a:srgbClr val="0B3D6E"/>
                 </a:solidFill>
                 <a:latin typeface="Calibri"/>
               </a:rPr>
@@ -7444,7 +7444,7 @@
                 <a:cs typeface="Calibri"/>
                 <a:ea typeface="Calibri"/>
                 <a:solidFill>
-                  <a:srgbClr val="2ED3B7"/>
+                  <a:srgbClr val="009EE0"/>
                 </a:solidFill>
                 <a:latin typeface="Calibri"/>
               </a:rPr>
@@ -7468,11 +7468,11 @@
             <a:avLst/>
           </a:prstGeom>
           <a:solidFill>
-            <a:srgbClr val="162A44"/>
+            <a:srgbClr val="FFFFFF"/>
           </a:solidFill>
           <a:ln>
             <a:solidFill>
-              <a:srgbClr val="2A405C"/>
+              <a:srgbClr val="B8D4EA"/>
             </a:solidFill>
           </a:ln>
         </p:spPr>
@@ -7528,7 +7528,7 @@
                 <a:cs typeface="Calibri"/>
                 <a:ea typeface="Calibri"/>
                 <a:solidFill>
-                  <a:srgbClr val="FFFFFF"/>
+                  <a:srgbClr val="0B3D6E"/>
                 </a:solidFill>
                 <a:latin typeface="Calibri"/>
               </a:rPr>
@@ -7546,7 +7546,7 @@
                 <a:cs typeface="Calibri"/>
                 <a:ea typeface="Calibri"/>
                 <a:solidFill>
-                  <a:srgbClr val="2ED3B7"/>
+                  <a:srgbClr val="009EE0"/>
                 </a:solidFill>
                 <a:latin typeface="Calibri"/>
               </a:rPr>
@@ -7570,11 +7570,11 @@
             <a:avLst/>
           </a:prstGeom>
           <a:solidFill>
-            <a:srgbClr val="162A44"/>
+            <a:srgbClr val="FFFFFF"/>
           </a:solidFill>
           <a:ln>
             <a:solidFill>
-              <a:srgbClr val="2A405C"/>
+              <a:srgbClr val="B8D4EA"/>
             </a:solidFill>
           </a:ln>
         </p:spPr>
@@ -7630,7 +7630,7 @@
                 <a:cs typeface="Calibri"/>
                 <a:ea typeface="Calibri"/>
                 <a:solidFill>
-                  <a:srgbClr val="FFFFFF"/>
+                  <a:srgbClr val="0B3D6E"/>
                 </a:solidFill>
                 <a:latin typeface="Calibri"/>
               </a:rPr>
@@ -7648,7 +7648,7 @@
                 <a:cs typeface="Calibri"/>
                 <a:ea typeface="Calibri"/>
                 <a:solidFill>
-                  <a:srgbClr val="2ED3B7"/>
+                  <a:srgbClr val="009EE0"/>
                 </a:solidFill>
                 <a:latin typeface="Calibri"/>
               </a:rPr>
@@ -7672,11 +7672,11 @@
             <a:avLst/>
           </a:prstGeom>
           <a:solidFill>
-            <a:srgbClr val="162A44"/>
+            <a:srgbClr val="FFFFFF"/>
           </a:solidFill>
           <a:ln>
             <a:solidFill>
-              <a:srgbClr val="2A405C"/>
+              <a:srgbClr val="B8D4EA"/>
             </a:solidFill>
           </a:ln>
         </p:spPr>
@@ -7732,7 +7732,7 @@
                 <a:cs typeface="Calibri"/>
                 <a:ea typeface="Calibri"/>
                 <a:solidFill>
-                  <a:srgbClr val="FFFFFF"/>
+                  <a:srgbClr val="0B3D6E"/>
                 </a:solidFill>
                 <a:latin typeface="Calibri"/>
               </a:rPr>
@@ -7750,7 +7750,7 @@
                 <a:cs typeface="Calibri"/>
                 <a:ea typeface="Calibri"/>
                 <a:solidFill>
-                  <a:srgbClr val="F5B32E"/>
+                  <a:srgbClr val="FF8C00"/>
                 </a:solidFill>
                 <a:latin typeface="Calibri"/>
               </a:rPr>
@@ -7774,11 +7774,11 @@
             <a:avLst/>
           </a:prstGeom>
           <a:solidFill>
-            <a:srgbClr val="162A44"/>
+            <a:srgbClr val="FFFFFF"/>
           </a:solidFill>
           <a:ln>
             <a:solidFill>
-              <a:srgbClr val="2A405C"/>
+              <a:srgbClr val="B8D4EA"/>
             </a:solidFill>
           </a:ln>
         </p:spPr>
@@ -7834,7 +7834,7 @@
                 <a:cs typeface="Calibri"/>
                 <a:ea typeface="Calibri"/>
                 <a:solidFill>
-                  <a:srgbClr val="FFFFFF"/>
+                  <a:srgbClr val="0B3D6E"/>
                 </a:solidFill>
                 <a:latin typeface="Calibri"/>
               </a:rPr>
@@ -7852,7 +7852,7 @@
                 <a:cs typeface="Calibri"/>
                 <a:ea typeface="Calibri"/>
                 <a:solidFill>
-                  <a:srgbClr val="2ED3B7"/>
+                  <a:srgbClr val="009EE0"/>
                 </a:solidFill>
                 <a:latin typeface="Calibri"/>
               </a:rPr>
@@ -7894,7 +7894,7 @@
             <a:avLst/>
           </a:prstGeom>
           <a:solidFill>
-            <a:srgbClr val="0B1422"/>
+            <a:srgbClr val="EFF8FF"/>
           </a:solidFill>
           <a:ln>
             <a:noFill/>
@@ -7937,7 +7937,7 @@
             <a:avLst/>
           </a:prstGeom>
           <a:solidFill>
-            <a:srgbClr val="2ED3B7"/>
+            <a:srgbClr val="009EE0"/>
           </a:solidFill>
           <a:ln>
             <a:noFill/>
@@ -7995,7 +7995,7 @@
                 <a:cs typeface="Calibri"/>
                 <a:ea typeface="Calibri"/>
                 <a:solidFill>
-                  <a:srgbClr val="F5B32E"/>
+                  <a:srgbClr val="FF8C00"/>
                 </a:solidFill>
                 <a:latin typeface="Calibri"/>
               </a:rPr>
@@ -8013,7 +8013,7 @@
                 <a:cs typeface="Calibri"/>
                 <a:ea typeface="Calibri"/>
                 <a:solidFill>
-                  <a:srgbClr val="FFFFFF"/>
+                  <a:srgbClr val="0B3D6E"/>
                 </a:solidFill>
                 <a:latin typeface="Calibri"/>
               </a:rPr>
@@ -8037,11 +8037,11 @@
             <a:avLst/>
           </a:prstGeom>
           <a:solidFill>
-            <a:srgbClr val="162A44"/>
+            <a:srgbClr val="FFFFFF"/>
           </a:solidFill>
           <a:ln>
             <a:solidFill>
-              <a:srgbClr val="2A405C"/>
+              <a:srgbClr val="B8D4EA"/>
             </a:solidFill>
           </a:ln>
         </p:spPr>
@@ -8097,7 +8097,7 @@
                 <a:cs typeface="Calibri"/>
                 <a:ea typeface="Calibri"/>
                 <a:solidFill>
-                  <a:srgbClr val="2ED3B7"/>
+                  <a:srgbClr val="009EE0"/>
                 </a:solidFill>
                 <a:latin typeface="Calibri"/>
               </a:rPr>
@@ -8115,7 +8115,7 @@
                 <a:cs typeface="Calibri"/>
                 <a:ea typeface="Calibri"/>
                 <a:solidFill>
-                  <a:srgbClr val="FFFFFF"/>
+                  <a:srgbClr val="0B3D6E"/>
                 </a:solidFill>
                 <a:latin typeface="Calibri"/>
               </a:rPr>
@@ -8133,7 +8133,7 @@
                 <a:cs typeface="Calibri"/>
                 <a:ea typeface="Calibri"/>
                 <a:solidFill>
-                  <a:srgbClr val="9AB0C6"/>
+                  <a:srgbClr val="3D556B"/>
                 </a:solidFill>
                 <a:latin typeface="Calibri"/>
               </a:rPr>
@@ -8157,11 +8157,11 @@
             <a:avLst/>
           </a:prstGeom>
           <a:solidFill>
-            <a:srgbClr val="162A44"/>
+            <a:srgbClr val="FFFFFF"/>
           </a:solidFill>
           <a:ln>
             <a:solidFill>
-              <a:srgbClr val="2A405C"/>
+              <a:srgbClr val="B8D4EA"/>
             </a:solidFill>
           </a:ln>
         </p:spPr>
@@ -8217,7 +8217,7 @@
                 <a:cs typeface="Calibri"/>
                 <a:ea typeface="Calibri"/>
                 <a:solidFill>
-                  <a:srgbClr val="2ED3B7"/>
+                  <a:srgbClr val="009EE0"/>
                 </a:solidFill>
                 <a:latin typeface="Calibri"/>
               </a:rPr>
@@ -8235,7 +8235,7 @@
                 <a:cs typeface="Calibri"/>
                 <a:ea typeface="Calibri"/>
                 <a:solidFill>
-                  <a:srgbClr val="FFFFFF"/>
+                  <a:srgbClr val="0B3D6E"/>
                 </a:solidFill>
                 <a:latin typeface="Calibri"/>
               </a:rPr>
@@ -8253,7 +8253,7 @@
                 <a:cs typeface="Calibri"/>
                 <a:ea typeface="Calibri"/>
                 <a:solidFill>
-                  <a:srgbClr val="9AB0C6"/>
+                  <a:srgbClr val="3D556B"/>
                 </a:solidFill>
                 <a:latin typeface="Calibri"/>
               </a:rPr>
@@ -8277,11 +8277,11 @@
             <a:avLst/>
           </a:prstGeom>
           <a:solidFill>
-            <a:srgbClr val="162A44"/>
+            <a:srgbClr val="FFFFFF"/>
           </a:solidFill>
           <a:ln>
             <a:solidFill>
-              <a:srgbClr val="2A405C"/>
+              <a:srgbClr val="B8D4EA"/>
             </a:solidFill>
           </a:ln>
         </p:spPr>
@@ -8337,7 +8337,7 @@
                 <a:cs typeface="Calibri"/>
                 <a:ea typeface="Calibri"/>
                 <a:solidFill>
-                  <a:srgbClr val="2ED3B7"/>
+                  <a:srgbClr val="009EE0"/>
                 </a:solidFill>
                 <a:latin typeface="Calibri"/>
               </a:rPr>
@@ -8355,7 +8355,7 @@
                 <a:cs typeface="Calibri"/>
                 <a:ea typeface="Calibri"/>
                 <a:solidFill>
-                  <a:srgbClr val="FFFFFF"/>
+                  <a:srgbClr val="0B3D6E"/>
                 </a:solidFill>
                 <a:latin typeface="Calibri"/>
               </a:rPr>
@@ -8373,7 +8373,7 @@
                 <a:cs typeface="Calibri"/>
                 <a:ea typeface="Calibri"/>
                 <a:solidFill>
-                  <a:srgbClr val="9AB0C6"/>
+                  <a:srgbClr val="3D556B"/>
                 </a:solidFill>
                 <a:latin typeface="Calibri"/>
               </a:rPr>
@@ -8397,11 +8397,11 @@
             <a:avLst/>
           </a:prstGeom>
           <a:solidFill>
-            <a:srgbClr val="162A44"/>
+            <a:srgbClr val="FFFFFF"/>
           </a:solidFill>
           <a:ln>
             <a:solidFill>
-              <a:srgbClr val="2A405C"/>
+              <a:srgbClr val="B8D4EA"/>
             </a:solidFill>
           </a:ln>
         </p:spPr>
@@ -8457,7 +8457,7 @@
                 <a:cs typeface="Calibri"/>
                 <a:ea typeface="Calibri"/>
                 <a:solidFill>
-                  <a:srgbClr val="F5B32E"/>
+                  <a:srgbClr val="FF8C00"/>
                 </a:solidFill>
                 <a:latin typeface="Calibri"/>
               </a:rPr>
@@ -8475,7 +8475,7 @@
                 <a:cs typeface="Calibri"/>
                 <a:ea typeface="Calibri"/>
                 <a:solidFill>
-                  <a:srgbClr val="FFFFFF"/>
+                  <a:srgbClr val="0B3D6E"/>
                 </a:solidFill>
                 <a:latin typeface="Calibri"/>
               </a:rPr>
@@ -8493,7 +8493,7 @@
                 <a:cs typeface="Calibri"/>
                 <a:ea typeface="Calibri"/>
                 <a:solidFill>
-                  <a:srgbClr val="9AB0C6"/>
+                  <a:srgbClr val="3D556B"/>
                 </a:solidFill>
                 <a:latin typeface="Calibri"/>
               </a:rPr>
@@ -8517,11 +8517,11 @@
             <a:avLst/>
           </a:prstGeom>
           <a:solidFill>
-            <a:srgbClr val="162A44"/>
+            <a:srgbClr val="FFFFFF"/>
           </a:solidFill>
           <a:ln>
             <a:solidFill>
-              <a:srgbClr val="2A405C"/>
+              <a:srgbClr val="B8D4EA"/>
             </a:solidFill>
           </a:ln>
         </p:spPr>
@@ -8577,7 +8577,7 @@
                 <a:cs typeface="Calibri"/>
                 <a:ea typeface="Calibri"/>
                 <a:solidFill>
-                  <a:srgbClr val="F5B32E"/>
+                  <a:srgbClr val="FF8C00"/>
                 </a:solidFill>
                 <a:latin typeface="Calibri"/>
               </a:rPr>
@@ -8595,7 +8595,7 @@
                 <a:cs typeface="Calibri"/>
                 <a:ea typeface="Calibri"/>
                 <a:solidFill>
-                  <a:srgbClr val="FFFFFF"/>
+                  <a:srgbClr val="0B3D6E"/>
                 </a:solidFill>
                 <a:latin typeface="Calibri"/>
               </a:rPr>
@@ -8613,7 +8613,7 @@
                 <a:cs typeface="Calibri"/>
                 <a:ea typeface="Calibri"/>
                 <a:solidFill>
-                  <a:srgbClr val="9AB0C6"/>
+                  <a:srgbClr val="3D556B"/>
                 </a:solidFill>
                 <a:latin typeface="Calibri"/>
               </a:rPr>
@@ -8655,7 +8655,7 @@
             <a:avLst/>
           </a:prstGeom>
           <a:solidFill>
-            <a:srgbClr val="0B1422"/>
+            <a:srgbClr val="EFF8FF"/>
           </a:solidFill>
           <a:ln>
             <a:noFill/>
@@ -8698,7 +8698,7 @@
             <a:avLst/>
           </a:prstGeom>
           <a:solidFill>
-            <a:srgbClr val="2ED3B7"/>
+            <a:srgbClr val="009EE0"/>
           </a:solidFill>
           <a:ln>
             <a:noFill/>
@@ -8741,7 +8741,7 @@
             <a:avLst/>
           </a:prstGeom>
           <a:solidFill>
-            <a:srgbClr val="153550"/>
+            <a:srgbClr val="FFB4C8"/>
           </a:solidFill>
           <a:ln>
             <a:noFill/>
@@ -8799,7 +8799,7 @@
                 <a:cs typeface="Calibri"/>
                 <a:ea typeface="Calibri"/>
                 <a:solidFill>
-                  <a:srgbClr val="2ED3B7"/>
+                  <a:srgbClr val="009EE0"/>
                 </a:solidFill>
                 <a:latin typeface="Calibri"/>
               </a:rPr>
@@ -8817,7 +8817,7 @@
                 <a:cs typeface="Calibri"/>
                 <a:ea typeface="Calibri"/>
                 <a:solidFill>
-                  <a:srgbClr val="FFFFFF"/>
+                  <a:srgbClr val="0B3D6E"/>
                 </a:solidFill>
                 <a:latin typeface="Calibri"/>
               </a:rPr>
@@ -8836,7 +8836,7 @@
                 <a:cs typeface="Calibri"/>
                 <a:ea typeface="Calibri"/>
                 <a:solidFill>
-                  <a:srgbClr val="9AB0C6"/>
+                  <a:srgbClr val="3D556B"/>
                 </a:solidFill>
                 <a:latin typeface="Calibri"/>
               </a:rPr>
@@ -8854,7 +8854,7 @@
                 <a:cs typeface="Calibri"/>
                 <a:ea typeface="Calibri"/>
                 <a:solidFill>
-                  <a:srgbClr val="F5B32E"/>
+                  <a:srgbClr val="FF8C00"/>
                 </a:solidFill>
                 <a:latin typeface="Calibri"/>
               </a:rPr>
@@ -8896,7 +8896,7 @@
             <a:avLst/>
           </a:prstGeom>
           <a:solidFill>
-            <a:srgbClr val="0B1422"/>
+            <a:srgbClr val="EFF8FF"/>
           </a:solidFill>
           <a:ln>
             <a:noFill/>
@@ -8939,7 +8939,7 @@
             <a:avLst/>
           </a:prstGeom>
           <a:solidFill>
-            <a:srgbClr val="2ED3B7"/>
+            <a:srgbClr val="009EE0"/>
           </a:solidFill>
           <a:ln>
             <a:noFill/>
@@ -8997,7 +8997,7 @@
                 <a:cs typeface="Calibri"/>
                 <a:ea typeface="Calibri"/>
                 <a:solidFill>
-                  <a:srgbClr val="2ED3B7"/>
+                  <a:srgbClr val="009EE0"/>
                 </a:solidFill>
                 <a:latin typeface="Calibri"/>
               </a:rPr>
@@ -9015,7 +9015,7 @@
                 <a:cs typeface="Calibri"/>
                 <a:ea typeface="Calibri"/>
                 <a:solidFill>
-                  <a:srgbClr val="FFFFFF"/>
+                  <a:srgbClr val="0B3D6E"/>
                 </a:solidFill>
                 <a:latin typeface="Calibri"/>
               </a:rPr>
@@ -9039,11 +9039,11 @@
             <a:avLst/>
           </a:prstGeom>
           <a:solidFill>
-            <a:srgbClr val="162A44"/>
+            <a:srgbClr val="FFFFFF"/>
           </a:solidFill>
           <a:ln>
             <a:solidFill>
-              <a:srgbClr val="2A405C"/>
+              <a:srgbClr val="B8D4EA"/>
             </a:solidFill>
           </a:ln>
         </p:spPr>
@@ -9099,7 +9099,7 @@
                 <a:cs typeface="Calibri"/>
                 <a:ea typeface="Calibri"/>
                 <a:solidFill>
-                  <a:srgbClr val="2ED3B7"/>
+                  <a:srgbClr val="009EE0"/>
                 </a:solidFill>
                 <a:latin typeface="Calibri"/>
               </a:rPr>
@@ -9117,7 +9117,7 @@
                 <a:cs typeface="Calibri"/>
                 <a:ea typeface="Calibri"/>
                 <a:solidFill>
-                  <a:srgbClr val="9AB0C6"/>
+                  <a:srgbClr val="3D556B"/>
                 </a:solidFill>
                 <a:latin typeface="Calibri"/>
               </a:rPr>
@@ -9142,11 +9142,11 @@
             <a:avLst/>
           </a:prstGeom>
           <a:solidFill>
-            <a:srgbClr val="162A44"/>
+            <a:srgbClr val="FFFFFF"/>
           </a:solidFill>
           <a:ln>
             <a:solidFill>
-              <a:srgbClr val="2A405C"/>
+              <a:srgbClr val="B8D4EA"/>
             </a:solidFill>
           </a:ln>
         </p:spPr>
@@ -9202,7 +9202,7 @@
                 <a:cs typeface="Calibri"/>
                 <a:ea typeface="Calibri"/>
                 <a:solidFill>
-                  <a:srgbClr val="F5B32E"/>
+                  <a:srgbClr val="FF8C00"/>
                 </a:solidFill>
                 <a:latin typeface="Calibri"/>
               </a:rPr>
@@ -9220,7 +9220,7 @@
                 <a:cs typeface="Calibri"/>
                 <a:ea typeface="Calibri"/>
                 <a:solidFill>
-                  <a:srgbClr val="9AB0C6"/>
+                  <a:srgbClr val="3D556B"/>
                 </a:solidFill>
                 <a:latin typeface="Calibri"/>
               </a:rPr>
@@ -9245,11 +9245,11 @@
             <a:avLst/>
           </a:prstGeom>
           <a:solidFill>
-            <a:srgbClr val="162A44"/>
+            <a:srgbClr val="FFFFFF"/>
           </a:solidFill>
           <a:ln>
             <a:solidFill>
-              <a:srgbClr val="2A405C"/>
+              <a:srgbClr val="B8D4EA"/>
             </a:solidFill>
           </a:ln>
         </p:spPr>
@@ -9305,7 +9305,7 @@
                 <a:cs typeface="Calibri"/>
                 <a:ea typeface="Calibri"/>
                 <a:solidFill>
-                  <a:srgbClr val="2ED3B7"/>
+                  <a:srgbClr val="009EE0"/>
                 </a:solidFill>
                 <a:latin typeface="Calibri"/>
               </a:rPr>
@@ -9323,7 +9323,7 @@
                 <a:cs typeface="Calibri"/>
                 <a:ea typeface="Calibri"/>
                 <a:solidFill>
-                  <a:srgbClr val="9AB0C6"/>
+                  <a:srgbClr val="3D556B"/>
                 </a:solidFill>
                 <a:latin typeface="Calibri"/>
               </a:rPr>
@@ -9348,11 +9348,11 @@
             <a:avLst/>
           </a:prstGeom>
           <a:solidFill>
-            <a:srgbClr val="162A44"/>
+            <a:srgbClr val="FFFFFF"/>
           </a:solidFill>
           <a:ln>
             <a:solidFill>
-              <a:srgbClr val="2A405C"/>
+              <a:srgbClr val="B8D4EA"/>
             </a:solidFill>
           </a:ln>
         </p:spPr>
@@ -9408,7 +9408,7 @@
                 <a:cs typeface="Calibri"/>
                 <a:ea typeface="Calibri"/>
                 <a:solidFill>
-                  <a:srgbClr val="F5B32E"/>
+                  <a:srgbClr val="FF8C00"/>
                 </a:solidFill>
                 <a:latin typeface="Calibri"/>
               </a:rPr>
@@ -9426,7 +9426,7 @@
                 <a:cs typeface="Calibri"/>
                 <a:ea typeface="Calibri"/>
                 <a:solidFill>
-                  <a:srgbClr val="9AB0C6"/>
+                  <a:srgbClr val="3D556B"/>
                 </a:solidFill>
                 <a:latin typeface="Calibri"/>
               </a:rPr>
@@ -9469,7 +9469,7 @@
             <a:avLst/>
           </a:prstGeom>
           <a:solidFill>
-            <a:srgbClr val="0B1422"/>
+            <a:srgbClr val="EFF8FF"/>
           </a:solidFill>
           <a:ln>
             <a:noFill/>
@@ -9512,7 +9512,7 @@
             <a:avLst/>
           </a:prstGeom>
           <a:solidFill>
-            <a:srgbClr val="2ED3B7"/>
+            <a:srgbClr val="009EE0"/>
           </a:solidFill>
           <a:ln>
             <a:noFill/>
@@ -9570,7 +9570,7 @@
                 <a:cs typeface="Calibri"/>
                 <a:ea typeface="Calibri"/>
                 <a:solidFill>
-                  <a:srgbClr val="2ED3B7"/>
+                  <a:srgbClr val="009EE0"/>
                 </a:solidFill>
                 <a:latin typeface="Calibri"/>
               </a:rPr>
@@ -9588,7 +9588,7 @@
                 <a:cs typeface="Calibri"/>
                 <a:ea typeface="Calibri"/>
                 <a:solidFill>
-                  <a:srgbClr val="FFFFFF"/>
+                  <a:srgbClr val="0B3D6E"/>
                 </a:solidFill>
                 <a:latin typeface="Calibri"/>
               </a:rPr>
@@ -9612,7 +9612,7 @@
             <a:avLst/>
           </a:prstGeom>
           <a:solidFill>
-            <a:srgbClr val="2ED3B7"/>
+            <a:srgbClr val="009EE0"/>
           </a:solidFill>
           <a:ln>
             <a:noFill/>
@@ -9670,7 +9670,7 @@
                 <a:cs typeface="Calibri"/>
                 <a:ea typeface="Calibri"/>
                 <a:solidFill>
-                  <a:srgbClr val="0B1422"/>
+                  <a:srgbClr val="FFFFFF"/>
                 </a:solidFill>
                 <a:latin typeface="Calibri"/>
               </a:rPr>
@@ -9709,7 +9709,7 @@
                 <a:cs typeface="Calibri"/>
                 <a:ea typeface="Calibri"/>
                 <a:solidFill>
-                  <a:srgbClr val="FFFFFF"/>
+                  <a:srgbClr val="0B3D6E"/>
                 </a:solidFill>
                 <a:latin typeface="Calibri"/>
               </a:rPr>
@@ -9727,7 +9727,7 @@
                 <a:cs typeface="Calibri"/>
                 <a:ea typeface="Calibri"/>
                 <a:solidFill>
-                  <a:srgbClr val="9AB0C6"/>
+                  <a:srgbClr val="3D556B"/>
                 </a:solidFill>
                 <a:latin typeface="Calibri"/>
               </a:rPr>
@@ -9751,7 +9751,7 @@
             <a:avLst/>
           </a:prstGeom>
           <a:solidFill>
-            <a:srgbClr val="2ED3B7"/>
+            <a:srgbClr val="009EE0"/>
           </a:solidFill>
           <a:ln>
             <a:noFill/>
@@ -9809,7 +9809,7 @@
                 <a:cs typeface="Calibri"/>
                 <a:ea typeface="Calibri"/>
                 <a:solidFill>
-                  <a:srgbClr val="0B1422"/>
+                  <a:srgbClr val="FFFFFF"/>
                 </a:solidFill>
                 <a:latin typeface="Calibri"/>
               </a:rPr>
@@ -9848,7 +9848,7 @@
                 <a:cs typeface="Calibri"/>
                 <a:ea typeface="Calibri"/>
                 <a:solidFill>
-                  <a:srgbClr val="FFFFFF"/>
+                  <a:srgbClr val="0B3D6E"/>
                 </a:solidFill>
                 <a:latin typeface="Calibri"/>
               </a:rPr>
@@ -9866,7 +9866,7 @@
                 <a:cs typeface="Calibri"/>
                 <a:ea typeface="Calibri"/>
                 <a:solidFill>
-                  <a:srgbClr val="9AB0C6"/>
+                  <a:srgbClr val="3D556B"/>
                 </a:solidFill>
                 <a:latin typeface="Calibri"/>
               </a:rPr>
@@ -9890,7 +9890,7 @@
             <a:avLst/>
           </a:prstGeom>
           <a:solidFill>
-            <a:srgbClr val="F5B32E"/>
+            <a:srgbClr val="FF8C00"/>
           </a:solidFill>
           <a:ln>
             <a:noFill/>
@@ -9948,7 +9948,7 @@
                 <a:cs typeface="Calibri"/>
                 <a:ea typeface="Calibri"/>
                 <a:solidFill>
-                  <a:srgbClr val="0B1422"/>
+                  <a:srgbClr val="FFFFFF"/>
                 </a:solidFill>
                 <a:latin typeface="Calibri"/>
               </a:rPr>
@@ -9987,7 +9987,7 @@
                 <a:cs typeface="Calibri"/>
                 <a:ea typeface="Calibri"/>
                 <a:solidFill>
-                  <a:srgbClr val="FFFFFF"/>
+                  <a:srgbClr val="0B3D6E"/>
                 </a:solidFill>
                 <a:latin typeface="Calibri"/>
               </a:rPr>
@@ -10005,7 +10005,7 @@
                 <a:cs typeface="Calibri"/>
                 <a:ea typeface="Calibri"/>
                 <a:solidFill>
-                  <a:srgbClr val="9AB0C6"/>
+                  <a:srgbClr val="3D556B"/>
                 </a:solidFill>
                 <a:latin typeface="Calibri"/>
               </a:rPr>
@@ -10047,7 +10047,7 @@
             <a:avLst/>
           </a:prstGeom>
           <a:solidFill>
-            <a:srgbClr val="0B1422"/>
+            <a:srgbClr val="EFF8FF"/>
           </a:solidFill>
           <a:ln>
             <a:noFill/>
@@ -10090,7 +10090,7 @@
             <a:avLst/>
           </a:prstGeom>
           <a:solidFill>
-            <a:srgbClr val="2ED3B7"/>
+            <a:srgbClr val="009EE0"/>
           </a:solidFill>
           <a:ln>
             <a:noFill/>
@@ -10148,7 +10148,7 @@
                 <a:cs typeface="Calibri"/>
                 <a:ea typeface="Calibri"/>
                 <a:solidFill>
-                  <a:srgbClr val="2ED3B7"/>
+                  <a:srgbClr val="009EE0"/>
                 </a:solidFill>
                 <a:latin typeface="Calibri"/>
               </a:rPr>
@@ -10166,7 +10166,7 @@
                 <a:cs typeface="Calibri"/>
                 <a:ea typeface="Calibri"/>
                 <a:solidFill>
-                  <a:srgbClr val="FFFFFF"/>
+                  <a:srgbClr val="0B3D6E"/>
                 </a:solidFill>
                 <a:latin typeface="Calibri"/>
               </a:rPr>
@@ -10190,11 +10190,11 @@
             <a:avLst/>
           </a:prstGeom>
           <a:solidFill>
-            <a:srgbClr val="162A44"/>
+            <a:srgbClr val="FFFFFF"/>
           </a:solidFill>
           <a:ln>
             <a:solidFill>
-              <a:srgbClr val="2A405C"/>
+              <a:srgbClr val="B8D4EA"/>
             </a:solidFill>
           </a:ln>
         </p:spPr>
@@ -10235,7 +10235,7 @@
             <a:avLst/>
           </a:prstGeom>
           <a:solidFill>
-            <a:srgbClr val="2ED3B7"/>
+            <a:srgbClr val="009EE0"/>
           </a:solidFill>
           <a:ln>
             <a:noFill/>
@@ -10293,7 +10293,7 @@
                 <a:cs typeface="Calibri"/>
                 <a:ea typeface="Calibri"/>
                 <a:solidFill>
-                  <a:srgbClr val="FFFFFF"/>
+                  <a:srgbClr val="0B3D6E"/>
                 </a:solidFill>
                 <a:latin typeface="Calibri"/>
               </a:rPr>
@@ -10311,7 +10311,7 @@
                 <a:cs typeface="Calibri"/>
                 <a:ea typeface="Calibri"/>
                 <a:solidFill>
-                  <a:srgbClr val="9AB0C6"/>
+                  <a:srgbClr val="3D556B"/>
                 </a:solidFill>
                 <a:latin typeface="Calibri"/>
               </a:rPr>
@@ -10351,7 +10351,7 @@
                 <a:cs typeface="Calibri"/>
                 <a:ea typeface="Calibri"/>
                 <a:solidFill>
-                  <a:srgbClr val="F5B32E"/>
+                  <a:srgbClr val="FF8C00"/>
                 </a:solidFill>
                 <a:latin typeface="Calibri"/>
               </a:rPr>
@@ -10375,11 +10375,11 @@
             <a:avLst/>
           </a:prstGeom>
           <a:solidFill>
-            <a:srgbClr val="162A44"/>
+            <a:srgbClr val="FFFFFF"/>
           </a:solidFill>
           <a:ln>
             <a:solidFill>
-              <a:srgbClr val="2A405C"/>
+              <a:srgbClr val="B8D4EA"/>
             </a:solidFill>
           </a:ln>
         </p:spPr>
@@ -10420,7 +10420,7 @@
             <a:avLst/>
           </a:prstGeom>
           <a:solidFill>
-            <a:srgbClr val="2ED3B7"/>
+            <a:srgbClr val="009EE0"/>
           </a:solidFill>
           <a:ln>
             <a:noFill/>
@@ -10478,7 +10478,7 @@
                 <a:cs typeface="Calibri"/>
                 <a:ea typeface="Calibri"/>
                 <a:solidFill>
-                  <a:srgbClr val="FFFFFF"/>
+                  <a:srgbClr val="0B3D6E"/>
                 </a:solidFill>
                 <a:latin typeface="Calibri"/>
               </a:rPr>
@@ -10496,7 +10496,7 @@
                 <a:cs typeface="Calibri"/>
                 <a:ea typeface="Calibri"/>
                 <a:solidFill>
-                  <a:srgbClr val="9AB0C6"/>
+                  <a:srgbClr val="3D556B"/>
                 </a:solidFill>
                 <a:latin typeface="Calibri"/>
               </a:rPr>
@@ -10536,7 +10536,7 @@
                 <a:cs typeface="Calibri"/>
                 <a:ea typeface="Calibri"/>
                 <a:solidFill>
-                  <a:srgbClr val="F5B32E"/>
+                  <a:srgbClr val="FF8C00"/>
                 </a:solidFill>
                 <a:latin typeface="Calibri"/>
               </a:rPr>
@@ -10560,11 +10560,11 @@
             <a:avLst/>
           </a:prstGeom>
           <a:solidFill>
-            <a:srgbClr val="162A44"/>
+            <a:srgbClr val="FFFFFF"/>
           </a:solidFill>
           <a:ln>
             <a:solidFill>
-              <a:srgbClr val="2A405C"/>
+              <a:srgbClr val="B8D4EA"/>
             </a:solidFill>
           </a:ln>
         </p:spPr>
@@ -10605,7 +10605,7 @@
             <a:avLst/>
           </a:prstGeom>
           <a:solidFill>
-            <a:srgbClr val="2ED3B7"/>
+            <a:srgbClr val="009EE0"/>
           </a:solidFill>
           <a:ln>
             <a:noFill/>
@@ -10663,7 +10663,7 @@
                 <a:cs typeface="Calibri"/>
                 <a:ea typeface="Calibri"/>
                 <a:solidFill>
-                  <a:srgbClr val="FFFFFF"/>
+                  <a:srgbClr val="0B3D6E"/>
                 </a:solidFill>
                 <a:latin typeface="Calibri"/>
               </a:rPr>
@@ -10681,7 +10681,7 @@
                 <a:cs typeface="Calibri"/>
                 <a:ea typeface="Calibri"/>
                 <a:solidFill>
-                  <a:srgbClr val="9AB0C6"/>
+                  <a:srgbClr val="3D556B"/>
                 </a:solidFill>
                 <a:latin typeface="Calibri"/>
               </a:rPr>
@@ -10721,7 +10721,7 @@
                 <a:cs typeface="Calibri"/>
                 <a:ea typeface="Calibri"/>
                 <a:solidFill>
-                  <a:srgbClr val="F5B32E"/>
+                  <a:srgbClr val="FF8C00"/>
                 </a:solidFill>
                 <a:latin typeface="Calibri"/>
               </a:rPr>
@@ -10745,11 +10745,11 @@
             <a:avLst/>
           </a:prstGeom>
           <a:solidFill>
-            <a:srgbClr val="162A44"/>
+            <a:srgbClr val="FFFFFF"/>
           </a:solidFill>
           <a:ln>
             <a:solidFill>
-              <a:srgbClr val="2A405C"/>
+              <a:srgbClr val="B8D4EA"/>
             </a:solidFill>
           </a:ln>
         </p:spPr>
@@ -10790,7 +10790,7 @@
             <a:avLst/>
           </a:prstGeom>
           <a:solidFill>
-            <a:srgbClr val="2ED3B7"/>
+            <a:srgbClr val="009EE0"/>
           </a:solidFill>
           <a:ln>
             <a:noFill/>
@@ -10848,7 +10848,7 @@
                 <a:cs typeface="Calibri"/>
                 <a:ea typeface="Calibri"/>
                 <a:solidFill>
-                  <a:srgbClr val="FFFFFF"/>
+                  <a:srgbClr val="0B3D6E"/>
                 </a:solidFill>
                 <a:latin typeface="Calibri"/>
               </a:rPr>
@@ -10866,7 +10866,7 @@
                 <a:cs typeface="Calibri"/>
                 <a:ea typeface="Calibri"/>
                 <a:solidFill>
-                  <a:srgbClr val="9AB0C6"/>
+                  <a:srgbClr val="3D556B"/>
                 </a:solidFill>
                 <a:latin typeface="Calibri"/>
               </a:rPr>
@@ -10906,7 +10906,7 @@
                 <a:cs typeface="Calibri"/>
                 <a:ea typeface="Calibri"/>
                 <a:solidFill>
-                  <a:srgbClr val="F5B32E"/>
+                  <a:srgbClr val="FF8C00"/>
                 </a:solidFill>
                 <a:latin typeface="Calibri"/>
               </a:rPr>
@@ -10930,11 +10930,11 @@
             <a:avLst/>
           </a:prstGeom>
           <a:solidFill>
-            <a:srgbClr val="162A44"/>
+            <a:srgbClr val="FFFFFF"/>
           </a:solidFill>
           <a:ln>
             <a:solidFill>
-              <a:srgbClr val="2A405C"/>
+              <a:srgbClr val="B8D4EA"/>
             </a:solidFill>
           </a:ln>
         </p:spPr>
@@ -10975,7 +10975,7 @@
             <a:avLst/>
           </a:prstGeom>
           <a:solidFill>
-            <a:srgbClr val="F5B32E"/>
+            <a:srgbClr val="FF8C00"/>
           </a:solidFill>
           <a:ln>
             <a:noFill/>
@@ -11033,7 +11033,7 @@
                 <a:cs typeface="Calibri"/>
                 <a:ea typeface="Calibri"/>
                 <a:solidFill>
-                  <a:srgbClr val="FFFFFF"/>
+                  <a:srgbClr val="0B3D6E"/>
                 </a:solidFill>
                 <a:latin typeface="Calibri"/>
               </a:rPr>
@@ -11051,7 +11051,7 @@
                 <a:cs typeface="Calibri"/>
                 <a:ea typeface="Calibri"/>
                 <a:solidFill>
-                  <a:srgbClr val="9AB0C6"/>
+                  <a:srgbClr val="3D556B"/>
                 </a:solidFill>
                 <a:latin typeface="Calibri"/>
               </a:rPr>
@@ -11094,7 +11094,7 @@
             <a:avLst/>
           </a:prstGeom>
           <a:solidFill>
-            <a:srgbClr val="0B1422"/>
+            <a:srgbClr val="EFF8FF"/>
           </a:solidFill>
           <a:ln>
             <a:noFill/>
@@ -11137,7 +11137,7 @@
             <a:avLst/>
           </a:prstGeom>
           <a:solidFill>
-            <a:srgbClr val="2ED3B7"/>
+            <a:srgbClr val="009EE0"/>
           </a:solidFill>
           <a:ln>
             <a:noFill/>
@@ -11195,7 +11195,7 @@
                 <a:cs typeface="Calibri"/>
                 <a:ea typeface="Calibri"/>
                 <a:solidFill>
-                  <a:srgbClr val="F5B32E"/>
+                  <a:srgbClr val="FF8C00"/>
                 </a:solidFill>
                 <a:latin typeface="Calibri"/>
               </a:rPr>
@@ -11213,7 +11213,7 @@
                 <a:cs typeface="Calibri"/>
                 <a:ea typeface="Calibri"/>
                 <a:solidFill>
-                  <a:srgbClr val="FFFFFF"/>
+                  <a:srgbClr val="0B3D6E"/>
                 </a:solidFill>
                 <a:latin typeface="Calibri"/>
               </a:rPr>
@@ -11237,11 +11237,11 @@
             <a:avLst/>
           </a:prstGeom>
           <a:solidFill>
-            <a:srgbClr val="162A44"/>
-          </a:solidFill>
-          <a:ln>
+            <a:srgbClr val="FFFFFF"/>
+          </a:solidFill>
+          <a:ln w="28575">
             <a:solidFill>
-              <a:srgbClr val="2A405C"/>
+              <a:srgbClr val="FF3D6E"/>
             </a:solidFill>
           </a:ln>
         </p:spPr>
@@ -11276,13 +11276,13 @@
         <p:spPr>
           <a:xfrm>
             <a:off x="640080" y="1645920"/>
-            <a:ext cx="91440" cy="4114800"/>
-          </a:xfrm>
-          <a:prstGeom prst="rect">
-            <a:avLst/>
-          </a:prstGeom>
-          <a:solidFill>
-            <a:srgbClr val="FF6B6B"/>
+            <a:ext cx="128016" cy="4114800"/>
+          </a:xfrm>
+          <a:prstGeom prst="rect">
+            <a:avLst/>
+          </a:prstGeom>
+          <a:solidFill>
+            <a:srgbClr val="FF3D6E"/>
           </a:solidFill>
           <a:ln>
             <a:noFill/>
@@ -11318,8 +11318,8 @@
         </p:nvSpPr>
         <p:spPr>
           <a:xfrm>
-            <a:off x="896112" y="1847088"/>
-            <a:ext cx="4937760" cy="3794760"/>
+            <a:off x="932688" y="1847088"/>
+            <a:ext cx="4892040" cy="3794760"/>
           </a:xfrm>
           <a:prstGeom prst="rect">
             <a:avLst/>
@@ -11340,7 +11340,7 @@
                 <a:cs typeface="Calibri"/>
                 <a:ea typeface="Calibri"/>
                 <a:solidFill>
-                  <a:srgbClr val="FFFFFF"/>
+                  <a:srgbClr val="0B3D6E"/>
                 </a:solidFill>
                 <a:latin typeface="Calibri"/>
               </a:rPr>
@@ -11358,7 +11358,7 @@
                 <a:cs typeface="Calibri"/>
                 <a:ea typeface="Calibri"/>
                 <a:solidFill>
-                  <a:srgbClr val="9AB0C6"/>
+                  <a:srgbClr val="3D556B"/>
                 </a:solidFill>
                 <a:latin typeface="Calibri"/>
               </a:rPr>
@@ -11385,11 +11385,11 @@
             <a:avLst/>
           </a:prstGeom>
           <a:solidFill>
-            <a:srgbClr val="162A44"/>
-          </a:solidFill>
-          <a:ln>
+            <a:srgbClr val="FFFFFF"/>
+          </a:solidFill>
+          <a:ln w="28575">
             <a:solidFill>
-              <a:srgbClr val="2A405C"/>
+              <a:srgbClr val="009EE0"/>
             </a:solidFill>
           </a:ln>
         </p:spPr>
@@ -11424,13 +11424,13 @@
         <p:spPr>
           <a:xfrm>
             <a:off x="6217920" y="1645920"/>
-            <a:ext cx="91440" cy="4114800"/>
-          </a:xfrm>
-          <a:prstGeom prst="rect">
-            <a:avLst/>
-          </a:prstGeom>
-          <a:solidFill>
-            <a:srgbClr val="2ED3B7"/>
+            <a:ext cx="128016" cy="4114800"/>
+          </a:xfrm>
+          <a:prstGeom prst="rect">
+            <a:avLst/>
+          </a:prstGeom>
+          <a:solidFill>
+            <a:srgbClr val="009EE0"/>
           </a:solidFill>
           <a:ln>
             <a:noFill/>
@@ -11466,8 +11466,8 @@
         </p:nvSpPr>
         <p:spPr>
           <a:xfrm>
-            <a:off x="6473952" y="1847088"/>
-            <a:ext cx="4937760" cy="3794760"/>
+            <a:off x="6510528" y="1847088"/>
+            <a:ext cx="4892040" cy="3794760"/>
           </a:xfrm>
           <a:prstGeom prst="rect">
             <a:avLst/>
@@ -11488,7 +11488,7 @@
                 <a:cs typeface="Calibri"/>
                 <a:ea typeface="Calibri"/>
                 <a:solidFill>
-                  <a:srgbClr val="FFFFFF"/>
+                  <a:srgbClr val="0B3D6E"/>
                 </a:solidFill>
                 <a:latin typeface="Calibri"/>
               </a:rPr>
@@ -11506,7 +11506,7 @@
                 <a:cs typeface="Calibri"/>
                 <a:ea typeface="Calibri"/>
                 <a:solidFill>
-                  <a:srgbClr val="9AB0C6"/>
+                  <a:srgbClr val="3D556B"/>
                 </a:solidFill>
                 <a:latin typeface="Calibri"/>
               </a:rPr>
@@ -11552,7 +11552,7 @@
             <a:avLst/>
           </a:prstGeom>
           <a:solidFill>
-            <a:srgbClr val="0B1422"/>
+            <a:srgbClr val="EFF8FF"/>
           </a:solidFill>
           <a:ln>
             <a:noFill/>
@@ -11595,7 +11595,7 @@
             <a:avLst/>
           </a:prstGeom>
           <a:solidFill>
-            <a:srgbClr val="2ED3B7"/>
+            <a:srgbClr val="009EE0"/>
           </a:solidFill>
           <a:ln>
             <a:noFill/>
@@ -11653,7 +11653,7 @@
                 <a:cs typeface="Calibri"/>
                 <a:ea typeface="Calibri"/>
                 <a:solidFill>
-                  <a:srgbClr val="2ED3B7"/>
+                  <a:srgbClr val="009EE0"/>
                 </a:solidFill>
                 <a:latin typeface="Calibri"/>
               </a:rPr>
@@ -11671,7 +11671,7 @@
                 <a:cs typeface="Calibri"/>
                 <a:ea typeface="Calibri"/>
                 <a:solidFill>
-                  <a:srgbClr val="FFFFFF"/>
+                  <a:srgbClr val="0B3D6E"/>
                 </a:solidFill>
                 <a:latin typeface="Calibri"/>
               </a:rPr>
@@ -11695,11 +11695,11 @@
             <a:avLst/>
           </a:prstGeom>
           <a:solidFill>
-            <a:srgbClr val="162A44"/>
-          </a:solidFill>
-          <a:ln>
+            <a:srgbClr val="FFFFFF"/>
+          </a:solidFill>
+          <a:ln w="28575">
             <a:solidFill>
-              <a:srgbClr val="2A405C"/>
+              <a:srgbClr val="3D556B"/>
             </a:solidFill>
           </a:ln>
         </p:spPr>
@@ -11734,13 +11734,13 @@
         <p:spPr>
           <a:xfrm>
             <a:off x="640080" y="1554480"/>
-            <a:ext cx="91440" cy="4206240"/>
-          </a:xfrm>
-          <a:prstGeom prst="rect">
-            <a:avLst/>
-          </a:prstGeom>
-          <a:solidFill>
-            <a:srgbClr val="9AB0C6"/>
+            <a:ext cx="128016" cy="4206240"/>
+          </a:xfrm>
+          <a:prstGeom prst="rect">
+            <a:avLst/>
+          </a:prstGeom>
+          <a:solidFill>
+            <a:srgbClr val="3D556B"/>
           </a:solidFill>
           <a:ln>
             <a:noFill/>
@@ -11776,8 +11776,8 @@
         </p:nvSpPr>
         <p:spPr>
           <a:xfrm>
-            <a:off x="896112" y="1755648"/>
-            <a:ext cx="3291840" cy="3886200"/>
+            <a:off x="932688" y="1755648"/>
+            <a:ext cx="3246120" cy="3886200"/>
           </a:xfrm>
           <a:prstGeom prst="rect">
             <a:avLst/>
@@ -11798,7 +11798,7 @@
                 <a:cs typeface="Calibri"/>
                 <a:ea typeface="Calibri"/>
                 <a:solidFill>
-                  <a:srgbClr val="FFFFFF"/>
+                  <a:srgbClr val="0B3D6E"/>
                 </a:solidFill>
                 <a:latin typeface="Calibri"/>
               </a:rPr>
@@ -11816,7 +11816,7 @@
                 <a:cs typeface="Calibri"/>
                 <a:ea typeface="Calibri"/>
                 <a:solidFill>
-                  <a:srgbClr val="9AB0C6"/>
+                  <a:srgbClr val="3D556B"/>
                 </a:solidFill>
                 <a:latin typeface="Calibri"/>
               </a:rPr>
@@ -11841,11 +11841,11 @@
             <a:avLst/>
           </a:prstGeom>
           <a:solidFill>
-            <a:srgbClr val="162A44"/>
-          </a:solidFill>
-          <a:ln>
+            <a:srgbClr val="FFFFFF"/>
+          </a:solidFill>
+          <a:ln w="28575">
             <a:solidFill>
-              <a:srgbClr val="2A405C"/>
+              <a:srgbClr val="009EE0"/>
             </a:solidFill>
           </a:ln>
         </p:spPr>
@@ -11880,13 +11880,13 @@
         <p:spPr>
           <a:xfrm>
             <a:off x="4526280" y="1554480"/>
-            <a:ext cx="91440" cy="4206240"/>
-          </a:xfrm>
-          <a:prstGeom prst="rect">
-            <a:avLst/>
-          </a:prstGeom>
-          <a:solidFill>
-            <a:srgbClr val="2ED3B7"/>
+            <a:ext cx="128016" cy="4206240"/>
+          </a:xfrm>
+          <a:prstGeom prst="rect">
+            <a:avLst/>
+          </a:prstGeom>
+          <a:solidFill>
+            <a:srgbClr val="009EE0"/>
           </a:solidFill>
           <a:ln>
             <a:noFill/>
@@ -11922,8 +11922,8 @@
         </p:nvSpPr>
         <p:spPr>
           <a:xfrm>
-            <a:off x="4782312" y="1755648"/>
-            <a:ext cx="3291840" cy="3886200"/>
+            <a:off x="4818888" y="1755648"/>
+            <a:ext cx="3246120" cy="3886200"/>
           </a:xfrm>
           <a:prstGeom prst="rect">
             <a:avLst/>
@@ -11944,7 +11944,7 @@
                 <a:cs typeface="Calibri"/>
                 <a:ea typeface="Calibri"/>
                 <a:solidFill>
-                  <a:srgbClr val="FFFFFF"/>
+                  <a:srgbClr val="0B3D6E"/>
                 </a:solidFill>
                 <a:latin typeface="Calibri"/>
               </a:rPr>
@@ -11962,7 +11962,7 @@
                 <a:cs typeface="Calibri"/>
                 <a:ea typeface="Calibri"/>
                 <a:solidFill>
-                  <a:srgbClr val="9AB0C6"/>
+                  <a:srgbClr val="3D556B"/>
                 </a:solidFill>
                 <a:latin typeface="Calibri"/>
               </a:rPr>
@@ -11988,11 +11988,11 @@
             <a:avLst/>
           </a:prstGeom>
           <a:solidFill>
-            <a:srgbClr val="162A44"/>
-          </a:solidFill>
-          <a:ln>
+            <a:srgbClr val="FFFFFF"/>
+          </a:solidFill>
+          <a:ln w="28575">
             <a:solidFill>
-              <a:srgbClr val="2A405C"/>
+              <a:srgbClr val="FF8C00"/>
             </a:solidFill>
           </a:ln>
         </p:spPr>
@@ -12027,13 +12027,13 @@
         <p:spPr>
           <a:xfrm>
             <a:off x="8412480" y="1554480"/>
-            <a:ext cx="91440" cy="4206240"/>
-          </a:xfrm>
-          <a:prstGeom prst="rect">
-            <a:avLst/>
-          </a:prstGeom>
-          <a:solidFill>
-            <a:srgbClr val="F5B32E"/>
+            <a:ext cx="128016" cy="4206240"/>
+          </a:xfrm>
+          <a:prstGeom prst="rect">
+            <a:avLst/>
+          </a:prstGeom>
+          <a:solidFill>
+            <a:srgbClr val="FF8C00"/>
           </a:solidFill>
           <a:ln>
             <a:noFill/>
@@ -12069,8 +12069,8 @@
         </p:nvSpPr>
         <p:spPr>
           <a:xfrm>
-            <a:off x="8668512" y="1755648"/>
-            <a:ext cx="2743200" cy="3886200"/>
+            <a:off x="8705088" y="1755648"/>
+            <a:ext cx="2697480" cy="3886200"/>
           </a:xfrm>
           <a:prstGeom prst="rect">
             <a:avLst/>
@@ -12091,7 +12091,7 @@
                 <a:cs typeface="Calibri"/>
                 <a:ea typeface="Calibri"/>
                 <a:solidFill>
-                  <a:srgbClr val="FFFFFF"/>
+                  <a:srgbClr val="0B3D6E"/>
                 </a:solidFill>
                 <a:latin typeface="Calibri"/>
               </a:rPr>
@@ -12109,7 +12109,7 @@
                 <a:cs typeface="Calibri"/>
                 <a:ea typeface="Calibri"/>
                 <a:solidFill>
-                  <a:srgbClr val="9AB0C6"/>
+                  <a:srgbClr val="3D556B"/>
                 </a:solidFill>
                 <a:latin typeface="Calibri"/>
               </a:rPr>
@@ -12153,7 +12153,7 @@
             <a:avLst/>
           </a:prstGeom>
           <a:solidFill>
-            <a:srgbClr val="0B1422"/>
+            <a:srgbClr val="EFF8FF"/>
           </a:solidFill>
           <a:ln>
             <a:noFill/>
@@ -12196,7 +12196,7 @@
             <a:avLst/>
           </a:prstGeom>
           <a:solidFill>
-            <a:srgbClr val="2ED3B7"/>
+            <a:srgbClr val="009EE0"/>
           </a:solidFill>
           <a:ln>
             <a:noFill/>
@@ -12254,7 +12254,7 @@
                 <a:cs typeface="Calibri"/>
                 <a:ea typeface="Calibri"/>
                 <a:solidFill>
-                  <a:srgbClr val="F5B32E"/>
+                  <a:srgbClr val="FF8C00"/>
                 </a:solidFill>
                 <a:latin typeface="Calibri"/>
               </a:rPr>
@@ -12272,7 +12272,7 @@
                 <a:cs typeface="Calibri"/>
                 <a:ea typeface="Calibri"/>
                 <a:solidFill>
-                  <a:srgbClr val="FFFFFF"/>
+                  <a:srgbClr val="0B3D6E"/>
                 </a:solidFill>
                 <a:latin typeface="Calibri"/>
               </a:rPr>
@@ -12296,11 +12296,11 @@
             <a:avLst/>
           </a:prstGeom>
           <a:solidFill>
-            <a:srgbClr val="162A44"/>
-          </a:solidFill>
-          <a:ln>
+            <a:srgbClr val="FFFFFF"/>
+          </a:solidFill>
+          <a:ln w="28575">
             <a:solidFill>
-              <a:srgbClr val="2A405C"/>
+              <a:srgbClr val="009EE0"/>
             </a:solidFill>
           </a:ln>
         </p:spPr>
@@ -12335,13 +12335,13 @@
         <p:spPr>
           <a:xfrm>
             <a:off x="502920" y="1508760"/>
-            <a:ext cx="91440" cy="2148840"/>
-          </a:xfrm>
-          <a:prstGeom prst="rect">
-            <a:avLst/>
-          </a:prstGeom>
-          <a:solidFill>
-            <a:srgbClr val="2ED3B7"/>
+            <a:ext cx="128016" cy="2148840"/>
+          </a:xfrm>
+          <a:prstGeom prst="rect">
+            <a:avLst/>
+          </a:prstGeom>
+          <a:solidFill>
+            <a:srgbClr val="009EE0"/>
           </a:solidFill>
           <a:ln>
             <a:noFill/>
@@ -12377,8 +12377,8 @@
         </p:nvSpPr>
         <p:spPr>
           <a:xfrm>
-            <a:off x="758952" y="1709928"/>
-            <a:ext cx="3291840" cy="1828800"/>
+            <a:off x="795528" y="1709928"/>
+            <a:ext cx="3246120" cy="1828800"/>
           </a:xfrm>
           <a:prstGeom prst="rect">
             <a:avLst/>
@@ -12399,7 +12399,7 @@
                 <a:cs typeface="Calibri"/>
                 <a:ea typeface="Calibri"/>
                 <a:solidFill>
-                  <a:srgbClr val="FFFFFF"/>
+                  <a:srgbClr val="0B3D6E"/>
                 </a:solidFill>
                 <a:latin typeface="Calibri"/>
               </a:rPr>
@@ -12417,7 +12417,7 @@
                 <a:cs typeface="Calibri"/>
                 <a:ea typeface="Calibri"/>
                 <a:solidFill>
-                  <a:srgbClr val="9AB0C6"/>
+                  <a:srgbClr val="3D556B"/>
                 </a:solidFill>
                 <a:latin typeface="Calibri"/>
               </a:rPr>
@@ -12441,11 +12441,11 @@
             <a:avLst/>
           </a:prstGeom>
           <a:solidFill>
-            <a:srgbClr val="162A44"/>
-          </a:solidFill>
-          <a:ln>
+            <a:srgbClr val="FFFFFF"/>
+          </a:solidFill>
+          <a:ln w="28575">
             <a:solidFill>
-              <a:srgbClr val="2A405C"/>
+              <a:srgbClr val="FF8C00"/>
             </a:solidFill>
           </a:ln>
         </p:spPr>
@@ -12480,13 +12480,13 @@
         <p:spPr>
           <a:xfrm>
             <a:off x="4343400" y="1508760"/>
-            <a:ext cx="91440" cy="2148840"/>
-          </a:xfrm>
-          <a:prstGeom prst="rect">
-            <a:avLst/>
-          </a:prstGeom>
-          <a:solidFill>
-            <a:srgbClr val="F5B32E"/>
+            <a:ext cx="128016" cy="2148840"/>
+          </a:xfrm>
+          <a:prstGeom prst="rect">
+            <a:avLst/>
+          </a:prstGeom>
+          <a:solidFill>
+            <a:srgbClr val="FF8C00"/>
           </a:solidFill>
           <a:ln>
             <a:noFill/>
@@ -12522,8 +12522,8 @@
         </p:nvSpPr>
         <p:spPr>
           <a:xfrm>
-            <a:off x="4599432" y="1709928"/>
-            <a:ext cx="3291840" cy="1828800"/>
+            <a:off x="4636008" y="1709928"/>
+            <a:ext cx="3246120" cy="1828800"/>
           </a:xfrm>
           <a:prstGeom prst="rect">
             <a:avLst/>
@@ -12544,7 +12544,7 @@
                 <a:cs typeface="Calibri"/>
                 <a:ea typeface="Calibri"/>
                 <a:solidFill>
-                  <a:srgbClr val="FFFFFF"/>
+                  <a:srgbClr val="0B3D6E"/>
                 </a:solidFill>
                 <a:latin typeface="Calibri"/>
               </a:rPr>
@@ -12562,7 +12562,7 @@
                 <a:cs typeface="Calibri"/>
                 <a:ea typeface="Calibri"/>
                 <a:solidFill>
-                  <a:srgbClr val="9AB0C6"/>
+                  <a:srgbClr val="3D556B"/>
                 </a:solidFill>
                 <a:latin typeface="Calibri"/>
               </a:rPr>
@@ -12586,11 +12586,11 @@
             <a:avLst/>
           </a:prstGeom>
           <a:solidFill>
-            <a:srgbClr val="162A44"/>
-          </a:solidFill>
-          <a:ln>
+            <a:srgbClr val="FFFFFF"/>
+          </a:solidFill>
+          <a:ln w="28575">
             <a:solidFill>
-              <a:srgbClr val="2A405C"/>
+              <a:srgbClr val="009EE0"/>
             </a:solidFill>
           </a:ln>
         </p:spPr>
@@ -12625,13 +12625,13 @@
         <p:spPr>
           <a:xfrm>
             <a:off x="8183880" y="1508760"/>
-            <a:ext cx="91440" cy="2148840"/>
-          </a:xfrm>
-          <a:prstGeom prst="rect">
-            <a:avLst/>
-          </a:prstGeom>
-          <a:solidFill>
-            <a:srgbClr val="2ED3B7"/>
+            <a:ext cx="128016" cy="2148840"/>
+          </a:xfrm>
+          <a:prstGeom prst="rect">
+            <a:avLst/>
+          </a:prstGeom>
+          <a:solidFill>
+            <a:srgbClr val="009EE0"/>
           </a:solidFill>
           <a:ln>
             <a:noFill/>
@@ -12667,8 +12667,8 @@
         </p:nvSpPr>
         <p:spPr>
           <a:xfrm>
-            <a:off x="8439912" y="1709928"/>
-            <a:ext cx="3291840" cy="1828800"/>
+            <a:off x="8476488" y="1709928"/>
+            <a:ext cx="3246120" cy="1828800"/>
           </a:xfrm>
           <a:prstGeom prst="rect">
             <a:avLst/>
@@ -12689,7 +12689,7 @@
                 <a:cs typeface="Calibri"/>
                 <a:ea typeface="Calibri"/>
                 <a:solidFill>
-                  <a:srgbClr val="FFFFFF"/>
+                  <a:srgbClr val="0B3D6E"/>
                 </a:solidFill>
                 <a:latin typeface="Calibri"/>
               </a:rPr>
@@ -12707,7 +12707,7 @@
                 <a:cs typeface="Calibri"/>
                 <a:ea typeface="Calibri"/>
                 <a:solidFill>
-                  <a:srgbClr val="9AB0C6"/>
+                  <a:srgbClr val="3D556B"/>
                 </a:solidFill>
                 <a:latin typeface="Calibri"/>
               </a:rPr>
@@ -12731,11 +12731,11 @@
             <a:avLst/>
           </a:prstGeom>
           <a:solidFill>
-            <a:srgbClr val="162A44"/>
-          </a:solidFill>
-          <a:ln>
+            <a:srgbClr val="FFFFFF"/>
+          </a:solidFill>
+          <a:ln w="28575">
             <a:solidFill>
-              <a:srgbClr val="2A405C"/>
+              <a:srgbClr val="FF8C00"/>
             </a:solidFill>
           </a:ln>
         </p:spPr>
@@ -12770,13 +12770,13 @@
         <p:spPr>
           <a:xfrm>
             <a:off x="502920" y="3840480"/>
-            <a:ext cx="91440" cy="2148840"/>
-          </a:xfrm>
-          <a:prstGeom prst="rect">
-            <a:avLst/>
-          </a:prstGeom>
-          <a:solidFill>
-            <a:srgbClr val="F5B32E"/>
+            <a:ext cx="128016" cy="2148840"/>
+          </a:xfrm>
+          <a:prstGeom prst="rect">
+            <a:avLst/>
+          </a:prstGeom>
+          <a:solidFill>
+            <a:srgbClr val="FF8C00"/>
           </a:solidFill>
           <a:ln>
             <a:noFill/>
@@ -12812,8 +12812,8 @@
         </p:nvSpPr>
         <p:spPr>
           <a:xfrm>
-            <a:off x="758952" y="4041648"/>
-            <a:ext cx="3291840" cy="1828800"/>
+            <a:off x="795528" y="4041648"/>
+            <a:ext cx="3246120" cy="1828800"/>
           </a:xfrm>
           <a:prstGeom prst="rect">
             <a:avLst/>
@@ -12834,7 +12834,7 @@
                 <a:cs typeface="Calibri"/>
                 <a:ea typeface="Calibri"/>
                 <a:solidFill>
-                  <a:srgbClr val="FFFFFF"/>
+                  <a:srgbClr val="0B3D6E"/>
                 </a:solidFill>
                 <a:latin typeface="Calibri"/>
               </a:rPr>
@@ -12852,7 +12852,7 @@
                 <a:cs typeface="Calibri"/>
                 <a:ea typeface="Calibri"/>
                 <a:solidFill>
-                  <a:srgbClr val="9AB0C6"/>
+                  <a:srgbClr val="3D556B"/>
                 </a:solidFill>
                 <a:latin typeface="Calibri"/>
               </a:rPr>
@@ -12876,11 +12876,11 @@
             <a:avLst/>
           </a:prstGeom>
           <a:solidFill>
-            <a:srgbClr val="162A44"/>
-          </a:solidFill>
-          <a:ln>
+            <a:srgbClr val="FFFFFF"/>
+          </a:solidFill>
+          <a:ln w="28575">
             <a:solidFill>
-              <a:srgbClr val="2A405C"/>
+              <a:srgbClr val="009EE0"/>
             </a:solidFill>
           </a:ln>
         </p:spPr>
@@ -12915,13 +12915,13 @@
         <p:spPr>
           <a:xfrm>
             <a:off x="4343400" y="3840480"/>
-            <a:ext cx="91440" cy="2148840"/>
-          </a:xfrm>
-          <a:prstGeom prst="rect">
-            <a:avLst/>
-          </a:prstGeom>
-          <a:solidFill>
-            <a:srgbClr val="2ED3B7"/>
+            <a:ext cx="128016" cy="2148840"/>
+          </a:xfrm>
+          <a:prstGeom prst="rect">
+            <a:avLst/>
+          </a:prstGeom>
+          <a:solidFill>
+            <a:srgbClr val="009EE0"/>
           </a:solidFill>
           <a:ln>
             <a:noFill/>
@@ -12957,8 +12957,8 @@
         </p:nvSpPr>
         <p:spPr>
           <a:xfrm>
-            <a:off x="4599432" y="4041648"/>
-            <a:ext cx="3291840" cy="1828800"/>
+            <a:off x="4636008" y="4041648"/>
+            <a:ext cx="3246120" cy="1828800"/>
           </a:xfrm>
           <a:prstGeom prst="rect">
             <a:avLst/>
@@ -12979,7 +12979,7 @@
                 <a:cs typeface="Calibri"/>
                 <a:ea typeface="Calibri"/>
                 <a:solidFill>
-                  <a:srgbClr val="FFFFFF"/>
+                  <a:srgbClr val="0B3D6E"/>
                 </a:solidFill>
                 <a:latin typeface="Calibri"/>
               </a:rPr>
@@ -12997,7 +12997,7 @@
                 <a:cs typeface="Calibri"/>
                 <a:ea typeface="Calibri"/>
                 <a:solidFill>
-                  <a:srgbClr val="9AB0C6"/>
+                  <a:srgbClr val="3D556B"/>
                 </a:solidFill>
                 <a:latin typeface="Calibri"/>
               </a:rPr>
@@ -13021,11 +13021,11 @@
             <a:avLst/>
           </a:prstGeom>
           <a:solidFill>
-            <a:srgbClr val="162A44"/>
-          </a:solidFill>
-          <a:ln>
+            <a:srgbClr val="FFFFFF"/>
+          </a:solidFill>
+          <a:ln w="28575">
             <a:solidFill>
-              <a:srgbClr val="2A405C"/>
+              <a:srgbClr val="FF8C00"/>
             </a:solidFill>
           </a:ln>
         </p:spPr>
@@ -13060,13 +13060,13 @@
         <p:spPr>
           <a:xfrm>
             <a:off x="8183880" y="3840480"/>
-            <a:ext cx="91440" cy="2148840"/>
-          </a:xfrm>
-          <a:prstGeom prst="rect">
-            <a:avLst/>
-          </a:prstGeom>
-          <a:solidFill>
-            <a:srgbClr val="F5B32E"/>
+            <a:ext cx="128016" cy="2148840"/>
+          </a:xfrm>
+          <a:prstGeom prst="rect">
+            <a:avLst/>
+          </a:prstGeom>
+          <a:solidFill>
+            <a:srgbClr val="FF8C00"/>
           </a:solidFill>
           <a:ln>
             <a:noFill/>
@@ -13102,8 +13102,8 @@
         </p:nvSpPr>
         <p:spPr>
           <a:xfrm>
-            <a:off x="8439912" y="4041648"/>
-            <a:ext cx="3291840" cy="1828800"/>
+            <a:off x="8476488" y="4041648"/>
+            <a:ext cx="3246120" cy="1828800"/>
           </a:xfrm>
           <a:prstGeom prst="rect">
             <a:avLst/>
@@ -13124,7 +13124,7 @@
                 <a:cs typeface="Calibri"/>
                 <a:ea typeface="Calibri"/>
                 <a:solidFill>
-                  <a:srgbClr val="FFFFFF"/>
+                  <a:srgbClr val="0B3D6E"/>
                 </a:solidFill>
                 <a:latin typeface="Calibri"/>
               </a:rPr>
@@ -13142,7 +13142,7 @@
                 <a:cs typeface="Calibri"/>
                 <a:ea typeface="Calibri"/>
                 <a:solidFill>
-                  <a:srgbClr val="9AB0C6"/>
+                  <a:srgbClr val="3D556B"/>
                 </a:solidFill>
                 <a:latin typeface="Calibri"/>
               </a:rPr>
@@ -13184,7 +13184,7 @@
             <a:avLst/>
           </a:prstGeom>
           <a:solidFill>
-            <a:srgbClr val="0B1422"/>
+            <a:srgbClr val="EFF8FF"/>
           </a:solidFill>
           <a:ln>
             <a:noFill/>
@@ -13227,7 +13227,7 @@
             <a:avLst/>
           </a:prstGeom>
           <a:solidFill>
-            <a:srgbClr val="2ED3B7"/>
+            <a:srgbClr val="009EE0"/>
           </a:solidFill>
           <a:ln>
             <a:noFill/>
@@ -13285,7 +13285,7 @@
                 <a:cs typeface="Calibri"/>
                 <a:ea typeface="Calibri"/>
                 <a:solidFill>
-                  <a:srgbClr val="2ED3B7"/>
+                  <a:srgbClr val="009EE0"/>
                 </a:solidFill>
                 <a:latin typeface="Calibri"/>
               </a:rPr>
@@ -13303,7 +13303,7 @@
                 <a:cs typeface="Calibri"/>
                 <a:ea typeface="Calibri"/>
                 <a:solidFill>
-                  <a:srgbClr val="FFFFFF"/>
+                  <a:srgbClr val="0B3D6E"/>
                 </a:solidFill>
                 <a:latin typeface="Calibri"/>
               </a:rPr>
@@ -13327,11 +13327,11 @@
             <a:avLst/>
           </a:prstGeom>
           <a:solidFill>
-            <a:srgbClr val="162A44"/>
+            <a:srgbClr val="FFFFFF"/>
           </a:solidFill>
           <a:ln>
             <a:solidFill>
-              <a:srgbClr val="2A405C"/>
+              <a:srgbClr val="B8D4EA"/>
             </a:solidFill>
           </a:ln>
         </p:spPr>
@@ -13372,7 +13372,7 @@
             <a:avLst/>
           </a:prstGeom>
           <a:solidFill>
-            <a:srgbClr val="F5B32E"/>
+            <a:srgbClr val="FF8C00"/>
           </a:solidFill>
           <a:ln>
             <a:noFill/>
@@ -13430,7 +13430,7 @@
                 <a:cs typeface="Calibri"/>
                 <a:ea typeface="Calibri"/>
                 <a:solidFill>
-                  <a:srgbClr val="FFFFFF"/>
+                  <a:srgbClr val="0B3D6E"/>
                 </a:solidFill>
                 <a:latin typeface="Calibri"/>
               </a:rPr>
@@ -13448,7 +13448,7 @@
                 <a:cs typeface="Calibri"/>
                 <a:ea typeface="Calibri"/>
                 <a:solidFill>
-                  <a:srgbClr val="9AB0C6"/>
+                  <a:srgbClr val="3D556B"/>
                 </a:solidFill>
                 <a:latin typeface="Calibri"/>
               </a:rPr>
@@ -13473,11 +13473,11 @@
             <a:avLst/>
           </a:prstGeom>
           <a:solidFill>
-            <a:srgbClr val="162A44"/>
+            <a:srgbClr val="FFFFFF"/>
           </a:solidFill>
           <a:ln>
             <a:solidFill>
-              <a:srgbClr val="2A405C"/>
+              <a:srgbClr val="B8D4EA"/>
             </a:solidFill>
           </a:ln>
         </p:spPr>
@@ -13518,7 +13518,7 @@
             <a:avLst/>
           </a:prstGeom>
           <a:solidFill>
-            <a:srgbClr val="2ED3B7"/>
+            <a:srgbClr val="009EE0"/>
           </a:solidFill>
           <a:ln>
             <a:noFill/>
@@ -13576,7 +13576,7 @@
                 <a:cs typeface="Calibri"/>
                 <a:ea typeface="Calibri"/>
                 <a:solidFill>
-                  <a:srgbClr val="FFFFFF"/>
+                  <a:srgbClr val="0B3D6E"/>
                 </a:solidFill>
                 <a:latin typeface="Calibri"/>
               </a:rPr>
@@ -13594,7 +13594,7 @@
                 <a:cs typeface="Calibri"/>
                 <a:ea typeface="Calibri"/>
                 <a:solidFill>
-                  <a:srgbClr val="9AB0C6"/>
+                  <a:srgbClr val="3D556B"/>
                 </a:solidFill>
                 <a:latin typeface="Calibri"/>
               </a:rPr>
@@ -13619,11 +13619,11 @@
             <a:avLst/>
           </a:prstGeom>
           <a:solidFill>
-            <a:srgbClr val="162A44"/>
+            <a:srgbClr val="FFFFFF"/>
           </a:solidFill>
           <a:ln>
             <a:solidFill>
-              <a:srgbClr val="2A405C"/>
+              <a:srgbClr val="B8D4EA"/>
             </a:solidFill>
           </a:ln>
         </p:spPr>
@@ -13722,7 +13722,7 @@
                 <a:cs typeface="Calibri"/>
                 <a:ea typeface="Calibri"/>
                 <a:solidFill>
-                  <a:srgbClr val="FFFFFF"/>
+                  <a:srgbClr val="0B3D6E"/>
                 </a:solidFill>
                 <a:latin typeface="Calibri"/>
               </a:rPr>
@@ -13740,7 +13740,7 @@
                 <a:cs typeface="Calibri"/>
                 <a:ea typeface="Calibri"/>
                 <a:solidFill>
-                  <a:srgbClr val="9AB0C6"/>
+                  <a:srgbClr val="3D556B"/>
                 </a:solidFill>
                 <a:latin typeface="Calibri"/>
               </a:rPr>
@@ -13765,11 +13765,11 @@
             <a:avLst/>
           </a:prstGeom>
           <a:solidFill>
-            <a:srgbClr val="162A44"/>
+            <a:srgbClr val="FFFFFF"/>
           </a:solidFill>
           <a:ln>
             <a:solidFill>
-              <a:srgbClr val="2A405C"/>
+              <a:srgbClr val="B8D4EA"/>
             </a:solidFill>
           </a:ln>
         </p:spPr>
@@ -13810,7 +13810,7 @@
             <a:avLst/>
           </a:prstGeom>
           <a:solidFill>
-            <a:srgbClr val="FF6B6B"/>
+            <a:srgbClr val="FF3D6E"/>
           </a:solidFill>
           <a:ln>
             <a:noFill/>
@@ -13868,7 +13868,7 @@
                 <a:cs typeface="Calibri"/>
                 <a:ea typeface="Calibri"/>
                 <a:solidFill>
-                  <a:srgbClr val="FFFFFF"/>
+                  <a:srgbClr val="0B3D6E"/>
                 </a:solidFill>
                 <a:latin typeface="Calibri"/>
               </a:rPr>
@@ -13886,7 +13886,7 @@
                 <a:cs typeface="Calibri"/>
                 <a:ea typeface="Calibri"/>
                 <a:solidFill>
-                  <a:srgbClr val="9AB0C6"/>
+                  <a:srgbClr val="3D556B"/>
                 </a:solidFill>
                 <a:latin typeface="Calibri"/>
               </a:rPr>
@@ -13911,11 +13911,11 @@
             <a:avLst/>
           </a:prstGeom>
           <a:solidFill>
-            <a:srgbClr val="162A44"/>
+            <a:srgbClr val="FFFFFF"/>
           </a:solidFill>
           <a:ln>
             <a:solidFill>
-              <a:srgbClr val="2A405C"/>
+              <a:srgbClr val="B8D4EA"/>
             </a:solidFill>
           </a:ln>
         </p:spPr>
@@ -14014,7 +14014,7 @@
                 <a:cs typeface="Calibri"/>
                 <a:ea typeface="Calibri"/>
                 <a:solidFill>
-                  <a:srgbClr val="FFFFFF"/>
+                  <a:srgbClr val="0B3D6E"/>
                 </a:solidFill>
                 <a:latin typeface="Calibri"/>
               </a:rPr>
@@ -14032,7 +14032,7 @@
                 <a:cs typeface="Calibri"/>
                 <a:ea typeface="Calibri"/>
                 <a:solidFill>
-                  <a:srgbClr val="9AB0C6"/>
+                  <a:srgbClr val="3D556B"/>
                 </a:solidFill>
                 <a:latin typeface="Calibri"/>
               </a:rPr>
@@ -14057,11 +14057,11 @@
             <a:avLst/>
           </a:prstGeom>
           <a:solidFill>
-            <a:srgbClr val="162A44"/>
+            <a:srgbClr val="FFFFFF"/>
           </a:solidFill>
           <a:ln>
             <a:solidFill>
-              <a:srgbClr val="2A405C"/>
+              <a:srgbClr val="B8D4EA"/>
             </a:solidFill>
           </a:ln>
         </p:spPr>
@@ -14160,7 +14160,7 @@
                 <a:cs typeface="Calibri"/>
                 <a:ea typeface="Calibri"/>
                 <a:solidFill>
-                  <a:srgbClr val="FFFFFF"/>
+                  <a:srgbClr val="0B3D6E"/>
                 </a:solidFill>
                 <a:latin typeface="Calibri"/>
               </a:rPr>
@@ -14178,7 +14178,7 @@
                 <a:cs typeface="Calibri"/>
                 <a:ea typeface="Calibri"/>
                 <a:solidFill>
-                  <a:srgbClr val="9AB0C6"/>
+                  <a:srgbClr val="3D556B"/>
                 </a:solidFill>
                 <a:latin typeface="Calibri"/>
               </a:rPr>
@@ -14221,7 +14221,7 @@
             <a:avLst/>
           </a:prstGeom>
           <a:solidFill>
-            <a:srgbClr val="0B1422"/>
+            <a:srgbClr val="EFF8FF"/>
           </a:solidFill>
           <a:ln>
             <a:noFill/>
@@ -14264,7 +14264,7 @@
             <a:avLst/>
           </a:prstGeom>
           <a:solidFill>
-            <a:srgbClr val="2ED3B7"/>
+            <a:srgbClr val="009EE0"/>
           </a:solidFill>
           <a:ln>
             <a:noFill/>
@@ -14307,7 +14307,7 @@
             <a:avLst/>
           </a:prstGeom>
           <a:solidFill>
-            <a:srgbClr val="0E3A2A"/>
+            <a:srgbClr val="7CF0B8"/>
           </a:solidFill>
           <a:ln>
             <a:noFill/>
@@ -14350,7 +14350,7 @@
             <a:avLst/>
           </a:prstGeom>
           <a:solidFill>
-            <a:srgbClr val="F5B32E"/>
+            <a:srgbClr val="FF8C00"/>
           </a:solidFill>
           <a:ln>
             <a:noFill/>
@@ -14408,7 +14408,7 @@
                 <a:cs typeface="Calibri"/>
                 <a:ea typeface="Calibri"/>
                 <a:solidFill>
-                  <a:srgbClr val="0B1422"/>
+                  <a:srgbClr val="EFF8FF"/>
                 </a:solidFill>
                 <a:latin typeface="Calibri"/>
               </a:rPr>
@@ -14447,7 +14447,7 @@
                 <a:cs typeface="Calibri"/>
                 <a:ea typeface="Calibri"/>
                 <a:solidFill>
-                  <a:srgbClr val="9AB0C6"/>
+                  <a:srgbClr val="3D556B"/>
                 </a:solidFill>
                 <a:latin typeface="Calibri"/>
               </a:rPr>
@@ -14465,7 +14465,7 @@
                 <a:cs typeface="Calibri"/>
                 <a:ea typeface="Calibri"/>
                 <a:solidFill>
-                  <a:srgbClr val="FFFFFF"/>
+                  <a:srgbClr val="0B3D6E"/>
                 </a:solidFill>
                 <a:latin typeface="Calibri"/>
               </a:rPr>
@@ -14483,7 +14483,7 @@
                 <a:cs typeface="Calibri"/>
                 <a:ea typeface="Calibri"/>
                 <a:solidFill>
-                  <a:srgbClr val="9AB0C6"/>
+                  <a:srgbClr val="3D556B"/>
                 </a:solidFill>
                 <a:latin typeface="Calibri"/>
               </a:rPr>

</xml_diff>

<commit_message>
Fix pill contrast and brighter framework accents
Co-authored-by: Dilshod Zokirov <DilshodZokirov@users.noreply.github.com>
</commit_message>
<xml_diff>
--- a/python-prezentatsiya/Python-Django-Vaaav.pptx
+++ b/python-prezentatsiya/Python-Django-Vaaav.pptx
@@ -3348,7 +3348,7 @@
                 <a:cs typeface="Calibri"/>
                 <a:ea typeface="Calibri"/>
                 <a:solidFill>
-                  <a:srgbClr val="EFF8FF"/>
+                  <a:srgbClr val="FFFFFF"/>
                 </a:solidFill>
                 <a:latin typeface="Calibri"/>
               </a:rPr>
@@ -13664,7 +13664,7 @@
             <a:avLst/>
           </a:prstGeom>
           <a:solidFill>
-            <a:srgbClr val="6EC6FF"/>
+            <a:srgbClr val="00B4FF"/>
           </a:solidFill>
           <a:ln>
             <a:noFill/>
@@ -13956,7 +13956,7 @@
             <a:avLst/>
           </a:prstGeom>
           <a:solidFill>
-            <a:srgbClr val="9BDEAC"/>
+            <a:srgbClr val="00C273"/>
           </a:solidFill>
           <a:ln>
             <a:noFill/>
@@ -14102,7 +14102,7 @@
             <a:avLst/>
           </a:prstGeom>
           <a:solidFill>
-            <a:srgbClr val="F7A1C4"/>
+            <a:srgbClr val="FF4F9A"/>
           </a:solidFill>
           <a:ln>
             <a:noFill/>
@@ -14408,7 +14408,7 @@
                 <a:cs typeface="Calibri"/>
                 <a:ea typeface="Calibri"/>
                 <a:solidFill>
-                  <a:srgbClr val="EFF8FF"/>
+                  <a:srgbClr val="FFFFFF"/>
                 </a:solidFill>
                 <a:latin typeface="Calibri"/>
               </a:rPr>

</xml_diff>

<commit_message>
Use coral accent instead of muted gray on memory slide
Co-authored-by: Dilshod Zokirov <DilshodZokirov@users.noreply.github.com>
</commit_message>
<xml_diff>
--- a/python-prezentatsiya/Python-Django-Vaaav.pptx
+++ b/python-prezentatsiya/Python-Django-Vaaav.pptx
@@ -11699,7 +11699,7 @@
           </a:solidFill>
           <a:ln w="28575">
             <a:solidFill>
-              <a:srgbClr val="3D556B"/>
+              <a:srgbClr val="FF3D6E"/>
             </a:solidFill>
           </a:ln>
         </p:spPr>
@@ -11740,7 +11740,7 @@
             <a:avLst/>
           </a:prstGeom>
           <a:solidFill>
-            <a:srgbClr val="3D556B"/>
+            <a:srgbClr val="FF3D6E"/>
           </a:solidFill>
           <a:ln>
             <a:noFill/>

</xml_diff>